<commit_message>
Make deck presentation-ready: real logo lockup + portrait cards
Replace the dashed 'placeholder' rectangles with designed elements
so the deck reads as finished on open, no external assets needed:

- Accutite logo lockup drawn from shapes: violet→cyan block-arc
  mark plus cyan diamond accent, "ACCUTITE / FASTENERS INC."
  wordmark underneath.
- Portrait slots on title, divider, and closing slides become
  gradient monogram cards ("LH") with name, role, and a caption
  line — still easy to replace with a real photo later.
- Helper to apply two-stop gradient fills in correct OOXML schema
  order (fill before a:ln), used for the logo mark and card washes.
</commit_message>
<xml_diff>
--- a/deck/Accutite_ChatGPT_Fastener_Deck.pptx
+++ b/deck/Accutite_ChatGPT_Fastener_Deck.pptx
@@ -3454,15 +3454,23 @@
         </p:nvSpPr>
         <p:spPr>
           <a:xfrm>
-            <a:off x="8229600" y="1188720"/>
+            <a:off x="8229600" y="1005840"/>
             <a:ext cx="3291840" cy="4754880"/>
           </a:xfrm>
           <a:prstGeom prst="roundRect">
             <a:avLst/>
           </a:prstGeom>
-          <a:solidFill>
-            <a:srgbClr val="0C1230"/>
-          </a:solidFill>
+          <a:gradFill flip="none" rotWithShape="1">
+            <a:gsLst>
+              <a:gs pos="0">
+                <a:srgbClr val="0C1230"/>
+              </a:gs>
+              <a:gs pos="100000">
+                <a:srgbClr val="04060F"/>
+              </a:gs>
+            </a:gsLst>
+            <a:lin ang="8100000" scaled="0"/>
+          </a:gradFill>
           <a:ln w="15875">
             <a:solidFill>
               <a:srgbClr val="9A7BFF"/>
@@ -3494,24 +3502,23 @@
       </p:sp>
       <p:sp>
         <p:nvSpPr>
-          <p:cNvPr id="11" name="Rounded Rectangle 10"/>
+          <p:cNvPr id="11" name="Oval 10"/>
           <p:cNvSpPr/>
           <p:nvPr/>
         </p:nvSpPr>
         <p:spPr>
           <a:xfrm>
-            <a:off x="8412480" y="1371600"/>
-            <a:ext cx="2926080" cy="4389120"/>
-          </a:xfrm>
-          <a:prstGeom prst="roundRect">
-            <a:avLst/>
-          </a:prstGeom>
-          <a:noFill/>
-          <a:ln w="6350">
-            <a:solidFill>
-              <a:srgbClr val="9A7BFF"/>
-            </a:solidFill>
-            <a:prstDash val="dash"/>
+            <a:off x="7772400" y="548640"/>
+            <a:ext cx="2962656" cy="2962656"/>
+          </a:xfrm>
+          <a:prstGeom prst="ellipse">
+            <a:avLst/>
+          </a:prstGeom>
+          <a:solidFill>
+            <a:srgbClr val="7C4DFF"/>
+          </a:solidFill>
+          <a:ln>
+            <a:noFill/>
           </a:ln>
           <a:effectLst/>
         </p:spPr>
@@ -3539,14 +3546,112 @@
       </p:sp>
       <p:sp>
         <p:nvSpPr>
-          <p:cNvPr id="12" name="TextBox 11"/>
+          <p:cNvPr id="12" name="Oval 11"/>
+          <p:cNvSpPr/>
+          <p:nvPr/>
+        </p:nvSpPr>
+        <p:spPr>
+          <a:xfrm>
+            <a:off x="9546336" y="3621024"/>
+            <a:ext cx="2633472" cy="2633472"/>
+          </a:xfrm>
+          <a:prstGeom prst="ellipse">
+            <a:avLst/>
+          </a:prstGeom>
+          <a:solidFill>
+            <a:srgbClr val="38E0FF"/>
+          </a:solidFill>
+          <a:ln>
+            <a:noFill/>
+          </a:ln>
+          <a:effectLst/>
+        </p:spPr>
+        <p:style>
+          <a:lnRef idx="1">
+            <a:schemeClr val="accent1"/>
+          </a:lnRef>
+          <a:fillRef idx="3">
+            <a:schemeClr val="accent1"/>
+          </a:fillRef>
+          <a:effectRef idx="2">
+            <a:schemeClr val="accent1"/>
+          </a:effectRef>
+          <a:fontRef idx="minor">
+            <a:schemeClr val="lt1"/>
+          </a:fontRef>
+        </p:style>
+        <p:txBody>
+          <a:bodyPr rtlCol="0" anchor="ctr"/>
+          <a:lstStyle/>
+          <a:p>
+            <a:pPr algn="ctr"/>
+          </a:p>
+        </p:txBody>
+      </p:sp>
+      <p:sp>
+        <p:nvSpPr>
+          <p:cNvPr id="13" name="Rounded Rectangle 12"/>
+          <p:cNvSpPr/>
+          <p:nvPr/>
+        </p:nvSpPr>
+        <p:spPr>
+          <a:xfrm>
+            <a:off x="8970264" y="1861718"/>
+            <a:ext cx="1810512" cy="1810512"/>
+          </a:xfrm>
+          <a:prstGeom prst="roundRect">
+            <a:avLst/>
+          </a:prstGeom>
+          <a:gradFill flip="none" rotWithShape="1">
+            <a:gsLst>
+              <a:gs pos="0">
+                <a:srgbClr val="121A44"/>
+              </a:gs>
+              <a:gs pos="100000">
+                <a:srgbClr val="04060F"/>
+              </a:gs>
+            </a:gsLst>
+            <a:lin ang="8100000" scaled="0"/>
+          </a:gradFill>
+          <a:ln w="19050">
+            <a:solidFill>
+              <a:srgbClr val="9A7BFF"/>
+            </a:solidFill>
+          </a:ln>
+          <a:effectLst/>
+        </p:spPr>
+        <p:style>
+          <a:lnRef idx="1">
+            <a:schemeClr val="accent1"/>
+          </a:lnRef>
+          <a:fillRef idx="3">
+            <a:schemeClr val="accent1"/>
+          </a:fillRef>
+          <a:effectRef idx="2">
+            <a:schemeClr val="accent1"/>
+          </a:effectRef>
+          <a:fontRef idx="minor">
+            <a:schemeClr val="lt1"/>
+          </a:fontRef>
+        </p:style>
+        <p:txBody>
+          <a:bodyPr rtlCol="0" anchor="ctr"/>
+          <a:lstStyle/>
+          <a:p>
+            <a:pPr algn="ctr"/>
+          </a:p>
+        </p:txBody>
+      </p:sp>
+      <p:sp>
+        <p:nvSpPr>
+          <p:cNvPr id="14" name="TextBox 13"/>
           <p:cNvSpPr txBox="1"/>
           <p:nvPr/>
         </p:nvSpPr>
         <p:spPr>
           <a:xfrm>
-            <a:off x="8229600" y="3383280"/>
-            <a:ext cx="3291840" cy="365760"/>
+            <a:off x="8970264" y="1861718"/>
+            <a:ext cx="1810512" cy="1810512"/>
           </a:xfrm>
           <a:prstGeom prst="rect">
             <a:avLst/>
@@ -3565,38 +3670,36 @@
               </a:lnSpc>
             </a:pPr>
             <a:r>
-              <a:rPr sz="1000" b="1" i="0" spc="300">
-                <a:solidFill>
-                  <a:srgbClr val="8EA0D6"/>
+              <a:rPr sz="9600" b="1" i="0" spc="100">
+                <a:solidFill>
+                  <a:srgbClr val="FFFFFF"/>
                 </a:solidFill>
                 <a:latin typeface="Calibri"/>
               </a:rPr>
-              <a:t>HERO PORTRAIT</a:t>
-            </a:r>
-          </a:p>
-        </p:txBody>
-      </p:sp>
-      <p:sp>
-        <p:nvSpPr>
-          <p:cNvPr id="13" name="Rounded Rectangle 12"/>
+              <a:t>LH</a:t>
+            </a:r>
+          </a:p>
+        </p:txBody>
+      </p:sp>
+      <p:sp>
+        <p:nvSpPr>
+          <p:cNvPr id="15" name="Rectangle 14"/>
           <p:cNvSpPr/>
           <p:nvPr/>
         </p:nvSpPr>
         <p:spPr>
           <a:xfrm>
-            <a:off x="9784080" y="6035040"/>
-            <a:ext cx="2194560" cy="640080"/>
-          </a:xfrm>
-          <a:prstGeom prst="roundRect">
+            <a:off x="9464040" y="3855110"/>
+            <a:ext cx="822960" cy="38100"/>
+          </a:xfrm>
+          <a:prstGeom prst="rect">
             <a:avLst/>
           </a:prstGeom>
           <a:solidFill>
-            <a:srgbClr val="0C1230"/>
+            <a:srgbClr val="38E0FF"/>
           </a:solidFill>
-          <a:ln w="9525">
-            <a:solidFill>
-              <a:srgbClr val="9A7BFF"/>
-            </a:solidFill>
+          <a:ln>
+            <a:noFill/>
           </a:ln>
           <a:effectLst/>
         </p:spPr>
@@ -3624,14 +3727,14 @@
       </p:sp>
       <p:sp>
         <p:nvSpPr>
-          <p:cNvPr id="14" name="TextBox 13"/>
+          <p:cNvPr id="16" name="TextBox 15"/>
           <p:cNvSpPr txBox="1"/>
           <p:nvPr/>
         </p:nvSpPr>
         <p:spPr>
           <a:xfrm>
-            <a:off x="9784080" y="6060440"/>
-            <a:ext cx="2194560" cy="320040"/>
+            <a:off x="8503920" y="4037990"/>
+            <a:ext cx="2743200" cy="365760"/>
           </a:xfrm>
           <a:prstGeom prst="rect">
             <a:avLst/>
@@ -3650,27 +3753,27 @@
               </a:lnSpc>
             </a:pPr>
             <a:r>
-              <a:rPr sz="1400" b="1" i="0" spc="400">
+              <a:rPr sz="1800" b="1" i="0">
                 <a:solidFill>
                   <a:srgbClr val="FFFFFF"/>
                 </a:solidFill>
                 <a:latin typeface="Calibri"/>
               </a:rPr>
-              <a:t>ACCUTITE</a:t>
-            </a:r>
-          </a:p>
-        </p:txBody>
-      </p:sp>
-      <p:sp>
-        <p:nvSpPr>
-          <p:cNvPr id="15" name="TextBox 14"/>
+              <a:t>LEVEE HEDRICK</a:t>
+            </a:r>
+          </a:p>
+        </p:txBody>
+      </p:sp>
+      <p:sp>
+        <p:nvSpPr>
+          <p:cNvPr id="17" name="TextBox 16"/>
           <p:cNvSpPr txBox="1"/>
           <p:nvPr/>
         </p:nvSpPr>
         <p:spPr>
           <a:xfrm>
-            <a:off x="9784080" y="6355080"/>
-            <a:ext cx="2194560" cy="320040"/>
+            <a:off x="8503920" y="4403750"/>
+            <a:ext cx="2743200" cy="320040"/>
           </a:xfrm>
           <a:prstGeom prst="rect">
             <a:avLst/>
@@ -3689,7 +3792,220 @@
               </a:lnSpc>
             </a:pPr>
             <a:r>
-              <a:rPr sz="800" b="1" i="0" spc="500">
+              <a:rPr sz="900" b="1" i="0" spc="400">
+                <a:solidFill>
+                  <a:srgbClr val="7EF0FF"/>
+                </a:solidFill>
+                <a:latin typeface="Calibri"/>
+              </a:rPr>
+              <a:t>MATERIAL CONTROL MANAGER</a:t>
+            </a:r>
+          </a:p>
+        </p:txBody>
+      </p:sp>
+      <p:sp>
+        <p:nvSpPr>
+          <p:cNvPr id="18" name="TextBox 17"/>
+          <p:cNvSpPr txBox="1"/>
+          <p:nvPr/>
+        </p:nvSpPr>
+        <p:spPr>
+          <a:xfrm>
+            <a:off x="8503920" y="4769510"/>
+            <a:ext cx="2743200" cy="274320"/>
+          </a:xfrm>
+          <a:prstGeom prst="rect">
+            <a:avLst/>
+          </a:prstGeom>
+          <a:noFill/>
+        </p:spPr>
+        <p:txBody>
+          <a:bodyPr wrap="square" lIns="0" rIns="0" tIns="0" bIns="0" anchor="ctr">
+            <a:spAutoFit/>
+          </a:bodyPr>
+          <a:lstStyle/>
+          <a:p>
+            <a:pPr algn="ctr">
+              <a:lnSpc>
+                <a:spcPct val="115000"/>
+              </a:lnSpc>
+            </a:pPr>
+            <a:r>
+              <a:rPr sz="800" b="0" i="1" spc="300">
+                <a:solidFill>
+                  <a:srgbClr val="8EA0D6"/>
+                </a:solidFill>
+                <a:latin typeface="Calibri"/>
+              </a:rPr>
+              <a:t>Accutite Fasteners, Inc.</a:t>
+            </a:r>
+          </a:p>
+        </p:txBody>
+      </p:sp>
+      <p:sp>
+        <p:nvSpPr>
+          <p:cNvPr id="19" name="Block Arc 18"/>
+          <p:cNvSpPr/>
+          <p:nvPr/>
+        </p:nvSpPr>
+        <p:spPr>
+          <a:xfrm>
+            <a:off x="1225296" y="5989320"/>
+            <a:ext cx="1207008" cy="603504"/>
+          </a:xfrm>
+          <a:prstGeom prst="blockArc">
+            <a:avLst/>
+          </a:prstGeom>
+          <a:gradFill flip="none" rotWithShape="1">
+            <a:gsLst>
+              <a:gs pos="0">
+                <a:srgbClr val="38E0FF"/>
+              </a:gs>
+              <a:gs pos="100000">
+                <a:srgbClr val="7C4DFF"/>
+              </a:gs>
+            </a:gsLst>
+            <a:lin ang="0" scaled="0"/>
+          </a:gradFill>
+          <a:ln>
+            <a:noFill/>
+          </a:ln>
+          <a:effectLst/>
+        </p:spPr>
+        <p:style>
+          <a:lnRef idx="1">
+            <a:schemeClr val="accent1"/>
+          </a:lnRef>
+          <a:fillRef idx="3">
+            <a:schemeClr val="accent1"/>
+          </a:fillRef>
+          <a:effectRef idx="2">
+            <a:schemeClr val="accent1"/>
+          </a:effectRef>
+          <a:fontRef idx="minor">
+            <a:schemeClr val="lt1"/>
+          </a:fontRef>
+        </p:style>
+        <p:txBody>
+          <a:bodyPr rtlCol="0" anchor="ctr"/>
+          <a:lstStyle/>
+          <a:p>
+            <a:pPr algn="ctr"/>
+          </a:p>
+        </p:txBody>
+      </p:sp>
+      <p:sp>
+        <p:nvSpPr>
+          <p:cNvPr id="20" name="Diamond 19"/>
+          <p:cNvSpPr/>
+          <p:nvPr/>
+        </p:nvSpPr>
+        <p:spPr>
+          <a:xfrm>
+            <a:off x="2371953" y="6079845"/>
+            <a:ext cx="132770" cy="132770"/>
+          </a:xfrm>
+          <a:prstGeom prst="diamond">
+            <a:avLst/>
+          </a:prstGeom>
+          <a:solidFill>
+            <a:srgbClr val="38E0FF"/>
+          </a:solidFill>
+          <a:ln>
+            <a:noFill/>
+          </a:ln>
+          <a:effectLst/>
+        </p:spPr>
+        <p:style>
+          <a:lnRef idx="1">
+            <a:schemeClr val="accent1"/>
+          </a:lnRef>
+          <a:fillRef idx="3">
+            <a:schemeClr val="accent1"/>
+          </a:fillRef>
+          <a:effectRef idx="2">
+            <a:schemeClr val="accent1"/>
+          </a:effectRef>
+          <a:fontRef idx="minor">
+            <a:schemeClr val="lt1"/>
+          </a:fontRef>
+        </p:style>
+        <p:txBody>
+          <a:bodyPr rtlCol="0" anchor="ctr"/>
+          <a:lstStyle/>
+          <a:p>
+            <a:pPr algn="ctr"/>
+          </a:p>
+        </p:txBody>
+      </p:sp>
+      <p:sp>
+        <p:nvSpPr>
+          <p:cNvPr id="21" name="TextBox 20"/>
+          <p:cNvSpPr txBox="1"/>
+          <p:nvPr/>
+        </p:nvSpPr>
+        <p:spPr>
+          <a:xfrm>
+            <a:off x="731520" y="6638544"/>
+            <a:ext cx="2194560" cy="310896"/>
+          </a:xfrm>
+          <a:prstGeom prst="rect">
+            <a:avLst/>
+          </a:prstGeom>
+          <a:noFill/>
+        </p:spPr>
+        <p:txBody>
+          <a:bodyPr wrap="square" lIns="0" rIns="0" tIns="0" bIns="0" anchor="ctr">
+            <a:spAutoFit/>
+          </a:bodyPr>
+          <a:lstStyle/>
+          <a:p>
+            <a:pPr algn="ctr">
+              <a:lnSpc>
+                <a:spcPct val="115000"/>
+              </a:lnSpc>
+            </a:pPr>
+            <a:r>
+              <a:rPr sz="1800" b="1" i="0" spc="450">
+                <a:solidFill>
+                  <a:srgbClr val="FFFFFF"/>
+                </a:solidFill>
+                <a:latin typeface="Calibri"/>
+              </a:rPr>
+              <a:t>ACCUTITE</a:t>
+            </a:r>
+          </a:p>
+        </p:txBody>
+      </p:sp>
+      <p:sp>
+        <p:nvSpPr>
+          <p:cNvPr id="22" name="TextBox 21"/>
+          <p:cNvSpPr txBox="1"/>
+          <p:nvPr/>
+        </p:nvSpPr>
+        <p:spPr>
+          <a:xfrm>
+            <a:off x="731520" y="6949440"/>
+            <a:ext cx="2194560" cy="201168"/>
+          </a:xfrm>
+          <a:prstGeom prst="rect">
+            <a:avLst/>
+          </a:prstGeom>
+          <a:noFill/>
+        </p:spPr>
+        <p:txBody>
+          <a:bodyPr wrap="square" lIns="0" rIns="0" tIns="0" bIns="0" anchor="ctr">
+            <a:spAutoFit/>
+          </a:bodyPr>
+          <a:lstStyle/>
+          <a:p>
+            <a:pPr algn="ctr">
+              <a:lnSpc>
+                <a:spcPct val="115000"/>
+              </a:lnSpc>
+            </a:pPr>
+            <a:r>
+              <a:rPr sz="900" b="1" i="0" spc="600">
                 <a:solidFill>
                   <a:srgbClr val="8EA0D6"/>
                 </a:solidFill>
@@ -4484,25 +4800,31 @@
       </p:sp>
       <p:sp>
         <p:nvSpPr>
-          <p:cNvPr id="17" name="Rounded Rectangle 16"/>
+          <p:cNvPr id="17" name="Block Arc 16"/>
           <p:cNvSpPr/>
           <p:nvPr/>
         </p:nvSpPr>
         <p:spPr>
           <a:xfrm>
-            <a:off x="10241280" y="320040"/>
-            <a:ext cx="1645920" cy="502920"/>
-          </a:xfrm>
-          <a:prstGeom prst="roundRect">
-            <a:avLst/>
-          </a:prstGeom>
-          <a:solidFill>
-            <a:srgbClr val="0C1230"/>
-          </a:solidFill>
-          <a:ln w="9525">
-            <a:solidFill>
-              <a:srgbClr val="9A7BFF"/>
-            </a:solidFill>
+            <a:off x="10611612" y="365760"/>
+            <a:ext cx="905256" cy="452628"/>
+          </a:xfrm>
+          <a:prstGeom prst="blockArc">
+            <a:avLst/>
+          </a:prstGeom>
+          <a:gradFill flip="none" rotWithShape="1">
+            <a:gsLst>
+              <a:gs pos="0">
+                <a:srgbClr val="38E0FF"/>
+              </a:gs>
+              <a:gs pos="100000">
+                <a:srgbClr val="7C4DFF"/>
+              </a:gs>
+            </a:gsLst>
+            <a:lin ang="0" scaled="0"/>
+          </a:gradFill>
+          <a:ln>
+            <a:noFill/>
           </a:ln>
           <a:effectLst/>
         </p:spPr>
@@ -4530,14 +4852,58 @@
       </p:sp>
       <p:sp>
         <p:nvSpPr>
-          <p:cNvPr id="18" name="TextBox 17"/>
+          <p:cNvPr id="18" name="Diamond 17"/>
+          <p:cNvSpPr/>
+          <p:nvPr/>
+        </p:nvSpPr>
+        <p:spPr>
+          <a:xfrm>
+            <a:off x="11471605" y="433654"/>
+            <a:ext cx="99578" cy="99578"/>
+          </a:xfrm>
+          <a:prstGeom prst="diamond">
+            <a:avLst/>
+          </a:prstGeom>
+          <a:solidFill>
+            <a:srgbClr val="38E0FF"/>
+          </a:solidFill>
+          <a:ln>
+            <a:noFill/>
+          </a:ln>
+          <a:effectLst/>
+        </p:spPr>
+        <p:style>
+          <a:lnRef idx="1">
+            <a:schemeClr val="accent1"/>
+          </a:lnRef>
+          <a:fillRef idx="3">
+            <a:schemeClr val="accent1"/>
+          </a:fillRef>
+          <a:effectRef idx="2">
+            <a:schemeClr val="accent1"/>
+          </a:effectRef>
+          <a:fontRef idx="minor">
+            <a:schemeClr val="lt1"/>
+          </a:fontRef>
+        </p:style>
+        <p:txBody>
+          <a:bodyPr rtlCol="0" anchor="ctr"/>
+          <a:lstStyle/>
+          <a:p>
+            <a:pPr algn="ctr"/>
+          </a:p>
+        </p:txBody>
+      </p:sp>
+      <p:sp>
+        <p:nvSpPr>
+          <p:cNvPr id="19" name="TextBox 18"/>
           <p:cNvSpPr txBox="1"/>
           <p:nvPr/>
         </p:nvSpPr>
         <p:spPr>
           <a:xfrm>
-            <a:off x="10241280" y="345440"/>
-            <a:ext cx="1645920" cy="251460"/>
+            <a:off x="10241280" y="864108"/>
+            <a:ext cx="1645920" cy="310896"/>
           </a:xfrm>
           <a:prstGeom prst="rect">
             <a:avLst/>
@@ -4556,7 +4922,7 @@
               </a:lnSpc>
             </a:pPr>
             <a:r>
-              <a:rPr sz="1100" b="1" i="0" spc="400">
+              <a:rPr sz="1800" b="1" i="0" spc="450">
                 <a:solidFill>
                   <a:srgbClr val="FFFFFF"/>
                 </a:solidFill>
@@ -4569,14 +4935,14 @@
       </p:sp>
       <p:sp>
         <p:nvSpPr>
-          <p:cNvPr id="19" name="TextBox 18"/>
+          <p:cNvPr id="20" name="TextBox 19"/>
           <p:cNvSpPr txBox="1"/>
           <p:nvPr/>
         </p:nvSpPr>
         <p:spPr>
           <a:xfrm>
-            <a:off x="10241280" y="571500"/>
-            <a:ext cx="1645920" cy="251460"/>
+            <a:off x="10241280" y="1175004"/>
+            <a:ext cx="1645920" cy="201168"/>
           </a:xfrm>
           <a:prstGeom prst="rect">
             <a:avLst/>
@@ -4595,7 +4961,7 @@
               </a:lnSpc>
             </a:pPr>
             <a:r>
-              <a:rPr sz="700" b="1" i="0" spc="500">
+              <a:rPr sz="900" b="1" i="0" spc="600">
                 <a:solidFill>
                   <a:srgbClr val="8EA0D6"/>
                 </a:solidFill>
@@ -5482,25 +5848,31 @@
       </p:sp>
       <p:sp>
         <p:nvSpPr>
-          <p:cNvPr id="22" name="Rounded Rectangle 21"/>
+          <p:cNvPr id="22" name="Block Arc 21"/>
           <p:cNvSpPr/>
           <p:nvPr/>
         </p:nvSpPr>
         <p:spPr>
           <a:xfrm>
-            <a:off x="10241280" y="320040"/>
-            <a:ext cx="1645920" cy="502920"/>
-          </a:xfrm>
-          <a:prstGeom prst="roundRect">
-            <a:avLst/>
-          </a:prstGeom>
-          <a:solidFill>
-            <a:srgbClr val="0C1230"/>
-          </a:solidFill>
-          <a:ln w="9525">
-            <a:solidFill>
-              <a:srgbClr val="9A7BFF"/>
-            </a:solidFill>
+            <a:off x="10611612" y="365760"/>
+            <a:ext cx="905256" cy="452628"/>
+          </a:xfrm>
+          <a:prstGeom prst="blockArc">
+            <a:avLst/>
+          </a:prstGeom>
+          <a:gradFill flip="none" rotWithShape="1">
+            <a:gsLst>
+              <a:gs pos="0">
+                <a:srgbClr val="38E0FF"/>
+              </a:gs>
+              <a:gs pos="100000">
+                <a:srgbClr val="7C4DFF"/>
+              </a:gs>
+            </a:gsLst>
+            <a:lin ang="0" scaled="0"/>
+          </a:gradFill>
+          <a:ln>
+            <a:noFill/>
           </a:ln>
           <a:effectLst/>
         </p:spPr>
@@ -5528,14 +5900,58 @@
       </p:sp>
       <p:sp>
         <p:nvSpPr>
-          <p:cNvPr id="23" name="TextBox 22"/>
+          <p:cNvPr id="23" name="Diamond 22"/>
+          <p:cNvSpPr/>
+          <p:nvPr/>
+        </p:nvSpPr>
+        <p:spPr>
+          <a:xfrm>
+            <a:off x="11471605" y="433654"/>
+            <a:ext cx="99578" cy="99578"/>
+          </a:xfrm>
+          <a:prstGeom prst="diamond">
+            <a:avLst/>
+          </a:prstGeom>
+          <a:solidFill>
+            <a:srgbClr val="38E0FF"/>
+          </a:solidFill>
+          <a:ln>
+            <a:noFill/>
+          </a:ln>
+          <a:effectLst/>
+        </p:spPr>
+        <p:style>
+          <a:lnRef idx="1">
+            <a:schemeClr val="accent1"/>
+          </a:lnRef>
+          <a:fillRef idx="3">
+            <a:schemeClr val="accent1"/>
+          </a:fillRef>
+          <a:effectRef idx="2">
+            <a:schemeClr val="accent1"/>
+          </a:effectRef>
+          <a:fontRef idx="minor">
+            <a:schemeClr val="lt1"/>
+          </a:fontRef>
+        </p:style>
+        <p:txBody>
+          <a:bodyPr rtlCol="0" anchor="ctr"/>
+          <a:lstStyle/>
+          <a:p>
+            <a:pPr algn="ctr"/>
+          </a:p>
+        </p:txBody>
+      </p:sp>
+      <p:sp>
+        <p:nvSpPr>
+          <p:cNvPr id="24" name="TextBox 23"/>
           <p:cNvSpPr txBox="1"/>
           <p:nvPr/>
         </p:nvSpPr>
         <p:spPr>
           <a:xfrm>
-            <a:off x="10241280" y="345440"/>
-            <a:ext cx="1645920" cy="251460"/>
+            <a:off x="10241280" y="864108"/>
+            <a:ext cx="1645920" cy="310896"/>
           </a:xfrm>
           <a:prstGeom prst="rect">
             <a:avLst/>
@@ -5554,7 +5970,7 @@
               </a:lnSpc>
             </a:pPr>
             <a:r>
-              <a:rPr sz="1100" b="1" i="0" spc="400">
+              <a:rPr sz="1800" b="1" i="0" spc="450">
                 <a:solidFill>
                   <a:srgbClr val="FFFFFF"/>
                 </a:solidFill>
@@ -5567,14 +5983,14 @@
       </p:sp>
       <p:sp>
         <p:nvSpPr>
-          <p:cNvPr id="24" name="TextBox 23"/>
+          <p:cNvPr id="25" name="TextBox 24"/>
           <p:cNvSpPr txBox="1"/>
           <p:nvPr/>
         </p:nvSpPr>
         <p:spPr>
           <a:xfrm>
-            <a:off x="10241280" y="571500"/>
-            <a:ext cx="1645920" cy="251460"/>
+            <a:off x="10241280" y="1175004"/>
+            <a:ext cx="1645920" cy="201168"/>
           </a:xfrm>
           <a:prstGeom prst="rect">
             <a:avLst/>
@@ -5593,7 +6009,7 @@
               </a:lnSpc>
             </a:pPr>
             <a:r>
-              <a:rPr sz="700" b="1" i="0" spc="500">
+              <a:rPr sz="900" b="1" i="0" spc="600">
                 <a:solidFill>
                   <a:srgbClr val="8EA0D6"/>
                 </a:solidFill>
@@ -5828,9 +6244,17 @@
           <a:prstGeom prst="roundRect">
             <a:avLst/>
           </a:prstGeom>
-          <a:solidFill>
-            <a:srgbClr val="0C1230"/>
-          </a:solidFill>
+          <a:gradFill flip="none" rotWithShape="1">
+            <a:gsLst>
+              <a:gs pos="0">
+                <a:srgbClr val="0C1230"/>
+              </a:gs>
+              <a:gs pos="100000">
+                <a:srgbClr val="04060F"/>
+              </a:gs>
+            </a:gsLst>
+            <a:lin ang="8100000" scaled="0"/>
+          </a:gradFill>
           <a:ln w="15875">
             <a:solidFill>
               <a:srgbClr val="9A7BFF"/>
@@ -5862,24 +6286,23 @@
       </p:sp>
       <p:sp>
         <p:nvSpPr>
-          <p:cNvPr id="7" name="Rounded Rectangle 6"/>
+          <p:cNvPr id="7" name="Oval 6"/>
           <p:cNvSpPr/>
           <p:nvPr/>
         </p:nvSpPr>
         <p:spPr>
           <a:xfrm>
-            <a:off x="822960" y="1097280"/>
-            <a:ext cx="3474720" cy="4663440"/>
-          </a:xfrm>
-          <a:prstGeom prst="roundRect">
-            <a:avLst/>
-          </a:prstGeom>
-          <a:noFill/>
-          <a:ln w="6350">
-            <a:solidFill>
-              <a:srgbClr val="9A7BFF"/>
-            </a:solidFill>
-            <a:prstDash val="dash"/>
+            <a:off x="182880" y="457200"/>
+            <a:ext cx="3456432" cy="3456432"/>
+          </a:xfrm>
+          <a:prstGeom prst="ellipse">
+            <a:avLst/>
+          </a:prstGeom>
+          <a:solidFill>
+            <a:srgbClr val="7C4DFF"/>
+          </a:solidFill>
+          <a:ln>
+            <a:noFill/>
           </a:ln>
           <a:effectLst/>
         </p:spPr>
@@ -5907,14 +6330,112 @@
       </p:sp>
       <p:sp>
         <p:nvSpPr>
-          <p:cNvPr id="8" name="TextBox 7"/>
+          <p:cNvPr id="8" name="Oval 7"/>
+          <p:cNvSpPr/>
+          <p:nvPr/>
+        </p:nvSpPr>
+        <p:spPr>
+          <a:xfrm>
+            <a:off x="2176272" y="3680460"/>
+            <a:ext cx="3072384" cy="3072384"/>
+          </a:xfrm>
+          <a:prstGeom prst="ellipse">
+            <a:avLst/>
+          </a:prstGeom>
+          <a:solidFill>
+            <a:srgbClr val="38E0FF"/>
+          </a:solidFill>
+          <a:ln>
+            <a:noFill/>
+          </a:ln>
+          <a:effectLst/>
+        </p:spPr>
+        <p:style>
+          <a:lnRef idx="1">
+            <a:schemeClr val="accent1"/>
+          </a:lnRef>
+          <a:fillRef idx="3">
+            <a:schemeClr val="accent1"/>
+          </a:fillRef>
+          <a:effectRef idx="2">
+            <a:schemeClr val="accent1"/>
+          </a:effectRef>
+          <a:fontRef idx="minor">
+            <a:schemeClr val="lt1"/>
+          </a:fontRef>
+        </p:style>
+        <p:txBody>
+          <a:bodyPr rtlCol="0" anchor="ctr"/>
+          <a:lstStyle/>
+          <a:p>
+            <a:pPr algn="ctr"/>
+          </a:p>
+        </p:txBody>
+      </p:sp>
+      <p:sp>
+        <p:nvSpPr>
+          <p:cNvPr id="9" name="Rounded Rectangle 8"/>
+          <p:cNvSpPr/>
+          <p:nvPr/>
+        </p:nvSpPr>
+        <p:spPr>
+          <a:xfrm>
+            <a:off x="1504188" y="1819656"/>
+            <a:ext cx="2112264" cy="2112264"/>
+          </a:xfrm>
+          <a:prstGeom prst="roundRect">
+            <a:avLst/>
+          </a:prstGeom>
+          <a:gradFill flip="none" rotWithShape="1">
+            <a:gsLst>
+              <a:gs pos="0">
+                <a:srgbClr val="121A44"/>
+              </a:gs>
+              <a:gs pos="100000">
+                <a:srgbClr val="04060F"/>
+              </a:gs>
+            </a:gsLst>
+            <a:lin ang="8100000" scaled="0"/>
+          </a:gradFill>
+          <a:ln w="19050">
+            <a:solidFill>
+              <a:srgbClr val="9A7BFF"/>
+            </a:solidFill>
+          </a:ln>
+          <a:effectLst/>
+        </p:spPr>
+        <p:style>
+          <a:lnRef idx="1">
+            <a:schemeClr val="accent1"/>
+          </a:lnRef>
+          <a:fillRef idx="3">
+            <a:schemeClr val="accent1"/>
+          </a:fillRef>
+          <a:effectRef idx="2">
+            <a:schemeClr val="accent1"/>
+          </a:effectRef>
+          <a:fontRef idx="minor">
+            <a:schemeClr val="lt1"/>
+          </a:fontRef>
+        </p:style>
+        <p:txBody>
+          <a:bodyPr rtlCol="0" anchor="ctr"/>
+          <a:lstStyle/>
+          <a:p>
+            <a:pPr algn="ctr"/>
+          </a:p>
+        </p:txBody>
+      </p:sp>
+      <p:sp>
+        <p:nvSpPr>
+          <p:cNvPr id="10" name="TextBox 9"/>
           <p:cNvSpPr txBox="1"/>
           <p:nvPr/>
         </p:nvSpPr>
         <p:spPr>
           <a:xfrm>
-            <a:off x="640080" y="3246120"/>
-            <a:ext cx="3840480" cy="365760"/>
+            <a:off x="1504188" y="1819656"/>
+            <a:ext cx="2112264" cy="2112264"/>
           </a:xfrm>
           <a:prstGeom prst="rect">
             <a:avLst/>
@@ -5933,20 +6454,181 @@
               </a:lnSpc>
             </a:pPr>
             <a:r>
-              <a:rPr sz="1000" b="1" i="0" spc="300">
-                <a:solidFill>
-                  <a:srgbClr val="8EA0D6"/>
+              <a:rPr sz="9600" b="1" i="0" spc="100">
+                <a:solidFill>
+                  <a:srgbClr val="FFFFFF"/>
                 </a:solidFill>
                 <a:latin typeface="Calibri"/>
               </a:rPr>
-              <a:t>SIDE PROFILE / FULL BODY</a:t>
-            </a:r>
-          </a:p>
-        </p:txBody>
-      </p:sp>
-      <p:sp>
-        <p:nvSpPr>
-          <p:cNvPr id="9" name="Rounded Rectangle 8"/>
+              <a:t>LH</a:t>
+            </a:r>
+          </a:p>
+        </p:txBody>
+      </p:sp>
+      <p:sp>
+        <p:nvSpPr>
+          <p:cNvPr id="11" name="Rectangle 10"/>
+          <p:cNvSpPr/>
+          <p:nvPr/>
+        </p:nvSpPr>
+        <p:spPr>
+          <a:xfrm>
+            <a:off x="2080260" y="4114800"/>
+            <a:ext cx="960120" cy="38100"/>
+          </a:xfrm>
+          <a:prstGeom prst="rect">
+            <a:avLst/>
+          </a:prstGeom>
+          <a:solidFill>
+            <a:srgbClr val="38E0FF"/>
+          </a:solidFill>
+          <a:ln>
+            <a:noFill/>
+          </a:ln>
+          <a:effectLst/>
+        </p:spPr>
+        <p:style>
+          <a:lnRef idx="1">
+            <a:schemeClr val="accent1"/>
+          </a:lnRef>
+          <a:fillRef idx="3">
+            <a:schemeClr val="accent1"/>
+          </a:fillRef>
+          <a:effectRef idx="2">
+            <a:schemeClr val="accent1"/>
+          </a:effectRef>
+          <a:fontRef idx="minor">
+            <a:schemeClr val="lt1"/>
+          </a:fontRef>
+        </p:style>
+        <p:txBody>
+          <a:bodyPr rtlCol="0" anchor="ctr"/>
+          <a:lstStyle/>
+          <a:p>
+            <a:pPr algn="ctr"/>
+          </a:p>
+        </p:txBody>
+      </p:sp>
+      <p:sp>
+        <p:nvSpPr>
+          <p:cNvPr id="12" name="TextBox 11"/>
+          <p:cNvSpPr txBox="1"/>
+          <p:nvPr/>
+        </p:nvSpPr>
+        <p:spPr>
+          <a:xfrm>
+            <a:off x="914400" y="4297680"/>
+            <a:ext cx="3291840" cy="365760"/>
+          </a:xfrm>
+          <a:prstGeom prst="rect">
+            <a:avLst/>
+          </a:prstGeom>
+          <a:noFill/>
+        </p:spPr>
+        <p:txBody>
+          <a:bodyPr wrap="square" lIns="0" rIns="0" tIns="0" bIns="0" anchor="ctr">
+            <a:spAutoFit/>
+          </a:bodyPr>
+          <a:lstStyle/>
+          <a:p>
+            <a:pPr algn="ctr">
+              <a:lnSpc>
+                <a:spcPct val="115000"/>
+              </a:lnSpc>
+            </a:pPr>
+            <a:r>
+              <a:rPr sz="1800" b="1" i="0">
+                <a:solidFill>
+                  <a:srgbClr val="FFFFFF"/>
+                </a:solidFill>
+                <a:latin typeface="Calibri"/>
+              </a:rPr>
+              <a:t>LEVEE HEDRICK</a:t>
+            </a:r>
+          </a:p>
+        </p:txBody>
+      </p:sp>
+      <p:sp>
+        <p:nvSpPr>
+          <p:cNvPr id="13" name="TextBox 12"/>
+          <p:cNvSpPr txBox="1"/>
+          <p:nvPr/>
+        </p:nvSpPr>
+        <p:spPr>
+          <a:xfrm>
+            <a:off x="914400" y="4663440"/>
+            <a:ext cx="3291840" cy="320040"/>
+          </a:xfrm>
+          <a:prstGeom prst="rect">
+            <a:avLst/>
+          </a:prstGeom>
+          <a:noFill/>
+        </p:spPr>
+        <p:txBody>
+          <a:bodyPr wrap="square" lIns="0" rIns="0" tIns="0" bIns="0" anchor="ctr">
+            <a:spAutoFit/>
+          </a:bodyPr>
+          <a:lstStyle/>
+          <a:p>
+            <a:pPr algn="ctr">
+              <a:lnSpc>
+                <a:spcPct val="115000"/>
+              </a:lnSpc>
+            </a:pPr>
+            <a:r>
+              <a:rPr sz="900" b="1" i="0" spc="400">
+                <a:solidFill>
+                  <a:srgbClr val="7EF0FF"/>
+                </a:solidFill>
+                <a:latin typeface="Calibri"/>
+              </a:rPr>
+              <a:t>MATERIAL CONTROL MANAGER</a:t>
+            </a:r>
+          </a:p>
+        </p:txBody>
+      </p:sp>
+      <p:sp>
+        <p:nvSpPr>
+          <p:cNvPr id="14" name="TextBox 13"/>
+          <p:cNvSpPr txBox="1"/>
+          <p:nvPr/>
+        </p:nvSpPr>
+        <p:spPr>
+          <a:xfrm>
+            <a:off x="914400" y="5029200"/>
+            <a:ext cx="3291840" cy="274320"/>
+          </a:xfrm>
+          <a:prstGeom prst="rect">
+            <a:avLst/>
+          </a:prstGeom>
+          <a:noFill/>
+        </p:spPr>
+        <p:txBody>
+          <a:bodyPr wrap="square" lIns="0" rIns="0" tIns="0" bIns="0" anchor="ctr">
+            <a:spAutoFit/>
+          </a:bodyPr>
+          <a:lstStyle/>
+          <a:p>
+            <a:pPr algn="ctr">
+              <a:lnSpc>
+                <a:spcPct val="115000"/>
+              </a:lnSpc>
+            </a:pPr>
+            <a:r>
+              <a:rPr sz="800" b="0" i="1" spc="300">
+                <a:solidFill>
+                  <a:srgbClr val="8EA0D6"/>
+                </a:solidFill>
+                <a:latin typeface="Calibri"/>
+              </a:rPr>
+              <a:t>Leading Purchasing &amp; Quality AI rollout</a:t>
+            </a:r>
+          </a:p>
+        </p:txBody>
+      </p:sp>
+      <p:sp>
+        <p:nvSpPr>
+          <p:cNvPr id="15" name="Rounded Rectangle 14"/>
           <p:cNvSpPr/>
           <p:nvPr/>
         </p:nvSpPr>
@@ -5994,7 +6676,7 @@
       </p:sp>
       <p:sp>
         <p:nvSpPr>
-          <p:cNvPr id="10" name="TextBox 9"/>
+          <p:cNvPr id="16" name="TextBox 15"/>
           <p:cNvSpPr txBox="1"/>
           <p:nvPr/>
         </p:nvSpPr>
@@ -6033,7 +6715,7 @@
       </p:sp>
       <p:sp>
         <p:nvSpPr>
-          <p:cNvPr id="11" name="TextBox 10"/>
+          <p:cNvPr id="17" name="TextBox 16"/>
           <p:cNvSpPr txBox="1"/>
           <p:nvPr/>
         </p:nvSpPr>
@@ -6072,7 +6754,7 @@
       </p:sp>
       <p:sp>
         <p:nvSpPr>
-          <p:cNvPr id="12" name="TextBox 11"/>
+          <p:cNvPr id="18" name="TextBox 17"/>
           <p:cNvSpPr txBox="1"/>
           <p:nvPr/>
         </p:nvSpPr>
@@ -6111,7 +6793,7 @@
       </p:sp>
       <p:sp>
         <p:nvSpPr>
-          <p:cNvPr id="13" name="Rectangle 12"/>
+          <p:cNvPr id="19" name="Rectangle 18"/>
           <p:cNvSpPr/>
           <p:nvPr/>
         </p:nvSpPr>
@@ -6155,7 +6837,7 @@
       </p:sp>
       <p:sp>
         <p:nvSpPr>
-          <p:cNvPr id="14" name="TextBox 13"/>
+          <p:cNvPr id="20" name="TextBox 19"/>
           <p:cNvSpPr txBox="1"/>
           <p:nvPr/>
         </p:nvSpPr>
@@ -6194,7 +6876,7 @@
       </p:sp>
       <p:sp>
         <p:nvSpPr>
-          <p:cNvPr id="15" name="TextBox 14"/>
+          <p:cNvPr id="21" name="TextBox 20"/>
           <p:cNvSpPr txBox="1"/>
           <p:nvPr/>
         </p:nvSpPr>
@@ -6233,7 +6915,7 @@
       </p:sp>
       <p:sp>
         <p:nvSpPr>
-          <p:cNvPr id="16" name="TextBox 15"/>
+          <p:cNvPr id="22" name="TextBox 21"/>
           <p:cNvSpPr txBox="1"/>
           <p:nvPr/>
         </p:nvSpPr>
@@ -7514,25 +8196,31 @@
       </p:sp>
       <p:sp>
         <p:nvSpPr>
-          <p:cNvPr id="31" name="Rounded Rectangle 30"/>
+          <p:cNvPr id="31" name="Block Arc 30"/>
           <p:cNvSpPr/>
           <p:nvPr/>
         </p:nvSpPr>
         <p:spPr>
           <a:xfrm>
-            <a:off x="10241280" y="320040"/>
-            <a:ext cx="1645920" cy="502920"/>
-          </a:xfrm>
-          <a:prstGeom prst="roundRect">
-            <a:avLst/>
-          </a:prstGeom>
-          <a:solidFill>
-            <a:srgbClr val="0C1230"/>
-          </a:solidFill>
-          <a:ln w="9525">
-            <a:solidFill>
-              <a:srgbClr val="9A7BFF"/>
-            </a:solidFill>
+            <a:off x="10611612" y="365760"/>
+            <a:ext cx="905256" cy="452628"/>
+          </a:xfrm>
+          <a:prstGeom prst="blockArc">
+            <a:avLst/>
+          </a:prstGeom>
+          <a:gradFill flip="none" rotWithShape="1">
+            <a:gsLst>
+              <a:gs pos="0">
+                <a:srgbClr val="38E0FF"/>
+              </a:gs>
+              <a:gs pos="100000">
+                <a:srgbClr val="7C4DFF"/>
+              </a:gs>
+            </a:gsLst>
+            <a:lin ang="0" scaled="0"/>
+          </a:gradFill>
+          <a:ln>
+            <a:noFill/>
           </a:ln>
           <a:effectLst/>
         </p:spPr>
@@ -7560,14 +8248,58 @@
       </p:sp>
       <p:sp>
         <p:nvSpPr>
-          <p:cNvPr id="32" name="TextBox 31"/>
+          <p:cNvPr id="32" name="Diamond 31"/>
+          <p:cNvSpPr/>
+          <p:nvPr/>
+        </p:nvSpPr>
+        <p:spPr>
+          <a:xfrm>
+            <a:off x="11471605" y="433654"/>
+            <a:ext cx="99578" cy="99578"/>
+          </a:xfrm>
+          <a:prstGeom prst="diamond">
+            <a:avLst/>
+          </a:prstGeom>
+          <a:solidFill>
+            <a:srgbClr val="38E0FF"/>
+          </a:solidFill>
+          <a:ln>
+            <a:noFill/>
+          </a:ln>
+          <a:effectLst/>
+        </p:spPr>
+        <p:style>
+          <a:lnRef idx="1">
+            <a:schemeClr val="accent1"/>
+          </a:lnRef>
+          <a:fillRef idx="3">
+            <a:schemeClr val="accent1"/>
+          </a:fillRef>
+          <a:effectRef idx="2">
+            <a:schemeClr val="accent1"/>
+          </a:effectRef>
+          <a:fontRef idx="minor">
+            <a:schemeClr val="lt1"/>
+          </a:fontRef>
+        </p:style>
+        <p:txBody>
+          <a:bodyPr rtlCol="0" anchor="ctr"/>
+          <a:lstStyle/>
+          <a:p>
+            <a:pPr algn="ctr"/>
+          </a:p>
+        </p:txBody>
+      </p:sp>
+      <p:sp>
+        <p:nvSpPr>
+          <p:cNvPr id="33" name="TextBox 32"/>
           <p:cNvSpPr txBox="1"/>
           <p:nvPr/>
         </p:nvSpPr>
         <p:spPr>
           <a:xfrm>
-            <a:off x="10241280" y="345440"/>
-            <a:ext cx="1645920" cy="251460"/>
+            <a:off x="10241280" y="864108"/>
+            <a:ext cx="1645920" cy="310896"/>
           </a:xfrm>
           <a:prstGeom prst="rect">
             <a:avLst/>
@@ -7586,7 +8318,7 @@
               </a:lnSpc>
             </a:pPr>
             <a:r>
-              <a:rPr sz="1100" b="1" i="0" spc="400">
+              <a:rPr sz="1800" b="1" i="0" spc="450">
                 <a:solidFill>
                   <a:srgbClr val="FFFFFF"/>
                 </a:solidFill>
@@ -7599,14 +8331,14 @@
       </p:sp>
       <p:sp>
         <p:nvSpPr>
-          <p:cNvPr id="33" name="TextBox 32"/>
+          <p:cNvPr id="34" name="TextBox 33"/>
           <p:cNvSpPr txBox="1"/>
           <p:nvPr/>
         </p:nvSpPr>
         <p:spPr>
           <a:xfrm>
-            <a:off x="10241280" y="571500"/>
-            <a:ext cx="1645920" cy="251460"/>
+            <a:off x="10241280" y="1175004"/>
+            <a:ext cx="1645920" cy="201168"/>
           </a:xfrm>
           <a:prstGeom prst="rect">
             <a:avLst/>
@@ -7625,7 +8357,7 @@
               </a:lnSpc>
             </a:pPr>
             <a:r>
-              <a:rPr sz="700" b="1" i="0" spc="500">
+              <a:rPr sz="900" b="1" i="0" spc="600">
                 <a:solidFill>
                   <a:srgbClr val="8EA0D6"/>
                 </a:solidFill>
@@ -8607,25 +9339,31 @@
       </p:sp>
       <p:sp>
         <p:nvSpPr>
-          <p:cNvPr id="24" name="Rounded Rectangle 23"/>
+          <p:cNvPr id="24" name="Block Arc 23"/>
           <p:cNvSpPr/>
           <p:nvPr/>
         </p:nvSpPr>
         <p:spPr>
           <a:xfrm>
-            <a:off x="10241280" y="320040"/>
-            <a:ext cx="1645920" cy="502920"/>
-          </a:xfrm>
-          <a:prstGeom prst="roundRect">
-            <a:avLst/>
-          </a:prstGeom>
-          <a:solidFill>
-            <a:srgbClr val="0C1230"/>
-          </a:solidFill>
-          <a:ln w="9525">
-            <a:solidFill>
-              <a:srgbClr val="9A7BFF"/>
-            </a:solidFill>
+            <a:off x="10611612" y="365760"/>
+            <a:ext cx="905256" cy="452628"/>
+          </a:xfrm>
+          <a:prstGeom prst="blockArc">
+            <a:avLst/>
+          </a:prstGeom>
+          <a:gradFill flip="none" rotWithShape="1">
+            <a:gsLst>
+              <a:gs pos="0">
+                <a:srgbClr val="38E0FF"/>
+              </a:gs>
+              <a:gs pos="100000">
+                <a:srgbClr val="7C4DFF"/>
+              </a:gs>
+            </a:gsLst>
+            <a:lin ang="0" scaled="0"/>
+          </a:gradFill>
+          <a:ln>
+            <a:noFill/>
           </a:ln>
           <a:effectLst/>
         </p:spPr>
@@ -8653,14 +9391,58 @@
       </p:sp>
       <p:sp>
         <p:nvSpPr>
-          <p:cNvPr id="25" name="TextBox 24"/>
+          <p:cNvPr id="25" name="Diamond 24"/>
+          <p:cNvSpPr/>
+          <p:nvPr/>
+        </p:nvSpPr>
+        <p:spPr>
+          <a:xfrm>
+            <a:off x="11471605" y="433654"/>
+            <a:ext cx="99578" cy="99578"/>
+          </a:xfrm>
+          <a:prstGeom prst="diamond">
+            <a:avLst/>
+          </a:prstGeom>
+          <a:solidFill>
+            <a:srgbClr val="38E0FF"/>
+          </a:solidFill>
+          <a:ln>
+            <a:noFill/>
+          </a:ln>
+          <a:effectLst/>
+        </p:spPr>
+        <p:style>
+          <a:lnRef idx="1">
+            <a:schemeClr val="accent1"/>
+          </a:lnRef>
+          <a:fillRef idx="3">
+            <a:schemeClr val="accent1"/>
+          </a:fillRef>
+          <a:effectRef idx="2">
+            <a:schemeClr val="accent1"/>
+          </a:effectRef>
+          <a:fontRef idx="minor">
+            <a:schemeClr val="lt1"/>
+          </a:fontRef>
+        </p:style>
+        <p:txBody>
+          <a:bodyPr rtlCol="0" anchor="ctr"/>
+          <a:lstStyle/>
+          <a:p>
+            <a:pPr algn="ctr"/>
+          </a:p>
+        </p:txBody>
+      </p:sp>
+      <p:sp>
+        <p:nvSpPr>
+          <p:cNvPr id="26" name="TextBox 25"/>
           <p:cNvSpPr txBox="1"/>
           <p:nvPr/>
         </p:nvSpPr>
         <p:spPr>
           <a:xfrm>
-            <a:off x="10241280" y="345440"/>
-            <a:ext cx="1645920" cy="251460"/>
+            <a:off x="10241280" y="864108"/>
+            <a:ext cx="1645920" cy="310896"/>
           </a:xfrm>
           <a:prstGeom prst="rect">
             <a:avLst/>
@@ -8679,7 +9461,7 @@
               </a:lnSpc>
             </a:pPr>
             <a:r>
-              <a:rPr sz="1100" b="1" i="0" spc="400">
+              <a:rPr sz="1800" b="1" i="0" spc="450">
                 <a:solidFill>
                   <a:srgbClr val="FFFFFF"/>
                 </a:solidFill>
@@ -8692,14 +9474,14 @@
       </p:sp>
       <p:sp>
         <p:nvSpPr>
-          <p:cNvPr id="26" name="TextBox 25"/>
+          <p:cNvPr id="27" name="TextBox 26"/>
           <p:cNvSpPr txBox="1"/>
           <p:nvPr/>
         </p:nvSpPr>
         <p:spPr>
           <a:xfrm>
-            <a:off x="10241280" y="571500"/>
-            <a:ext cx="1645920" cy="251460"/>
+            <a:off x="10241280" y="1175004"/>
+            <a:ext cx="1645920" cy="201168"/>
           </a:xfrm>
           <a:prstGeom prst="rect">
             <a:avLst/>
@@ -8718,7 +9500,7 @@
               </a:lnSpc>
             </a:pPr>
             <a:r>
-              <a:rPr sz="700" b="1" i="0" spc="500">
+              <a:rPr sz="900" b="1" i="0" spc="600">
                 <a:solidFill>
                   <a:srgbClr val="8EA0D6"/>
                 </a:solidFill>
@@ -9782,25 +10564,31 @@
       </p:sp>
       <p:sp>
         <p:nvSpPr>
-          <p:cNvPr id="26" name="Rounded Rectangle 25"/>
+          <p:cNvPr id="26" name="Block Arc 25"/>
           <p:cNvSpPr/>
           <p:nvPr/>
         </p:nvSpPr>
         <p:spPr>
           <a:xfrm>
-            <a:off x="10241280" y="320040"/>
-            <a:ext cx="1645920" cy="502920"/>
-          </a:xfrm>
-          <a:prstGeom prst="roundRect">
-            <a:avLst/>
-          </a:prstGeom>
-          <a:solidFill>
-            <a:srgbClr val="0C1230"/>
-          </a:solidFill>
-          <a:ln w="9525">
-            <a:solidFill>
-              <a:srgbClr val="9A7BFF"/>
-            </a:solidFill>
+            <a:off x="10611612" y="365760"/>
+            <a:ext cx="905256" cy="452628"/>
+          </a:xfrm>
+          <a:prstGeom prst="blockArc">
+            <a:avLst/>
+          </a:prstGeom>
+          <a:gradFill flip="none" rotWithShape="1">
+            <a:gsLst>
+              <a:gs pos="0">
+                <a:srgbClr val="38E0FF"/>
+              </a:gs>
+              <a:gs pos="100000">
+                <a:srgbClr val="7C4DFF"/>
+              </a:gs>
+            </a:gsLst>
+            <a:lin ang="0" scaled="0"/>
+          </a:gradFill>
+          <a:ln>
+            <a:noFill/>
           </a:ln>
           <a:effectLst/>
         </p:spPr>
@@ -9828,14 +10616,58 @@
       </p:sp>
       <p:sp>
         <p:nvSpPr>
-          <p:cNvPr id="27" name="TextBox 26"/>
+          <p:cNvPr id="27" name="Diamond 26"/>
+          <p:cNvSpPr/>
+          <p:nvPr/>
+        </p:nvSpPr>
+        <p:spPr>
+          <a:xfrm>
+            <a:off x="11471605" y="433654"/>
+            <a:ext cx="99578" cy="99578"/>
+          </a:xfrm>
+          <a:prstGeom prst="diamond">
+            <a:avLst/>
+          </a:prstGeom>
+          <a:solidFill>
+            <a:srgbClr val="38E0FF"/>
+          </a:solidFill>
+          <a:ln>
+            <a:noFill/>
+          </a:ln>
+          <a:effectLst/>
+        </p:spPr>
+        <p:style>
+          <a:lnRef idx="1">
+            <a:schemeClr val="accent1"/>
+          </a:lnRef>
+          <a:fillRef idx="3">
+            <a:schemeClr val="accent1"/>
+          </a:fillRef>
+          <a:effectRef idx="2">
+            <a:schemeClr val="accent1"/>
+          </a:effectRef>
+          <a:fontRef idx="minor">
+            <a:schemeClr val="lt1"/>
+          </a:fontRef>
+        </p:style>
+        <p:txBody>
+          <a:bodyPr rtlCol="0" anchor="ctr"/>
+          <a:lstStyle/>
+          <a:p>
+            <a:pPr algn="ctr"/>
+          </a:p>
+        </p:txBody>
+      </p:sp>
+      <p:sp>
+        <p:nvSpPr>
+          <p:cNvPr id="28" name="TextBox 27"/>
           <p:cNvSpPr txBox="1"/>
           <p:nvPr/>
         </p:nvSpPr>
         <p:spPr>
           <a:xfrm>
-            <a:off x="10241280" y="345440"/>
-            <a:ext cx="1645920" cy="251460"/>
+            <a:off x="10241280" y="864108"/>
+            <a:ext cx="1645920" cy="310896"/>
           </a:xfrm>
           <a:prstGeom prst="rect">
             <a:avLst/>
@@ -9854,7 +10686,7 @@
               </a:lnSpc>
             </a:pPr>
             <a:r>
-              <a:rPr sz="1100" b="1" i="0" spc="400">
+              <a:rPr sz="1800" b="1" i="0" spc="450">
                 <a:solidFill>
                   <a:srgbClr val="FFFFFF"/>
                 </a:solidFill>
@@ -9867,14 +10699,14 @@
       </p:sp>
       <p:sp>
         <p:nvSpPr>
-          <p:cNvPr id="28" name="TextBox 27"/>
+          <p:cNvPr id="29" name="TextBox 28"/>
           <p:cNvSpPr txBox="1"/>
           <p:nvPr/>
         </p:nvSpPr>
         <p:spPr>
           <a:xfrm>
-            <a:off x="10241280" y="571500"/>
-            <a:ext cx="1645920" cy="251460"/>
+            <a:off x="10241280" y="1175004"/>
+            <a:ext cx="1645920" cy="201168"/>
           </a:xfrm>
           <a:prstGeom prst="rect">
             <a:avLst/>
@@ -9893,7 +10725,7 @@
               </a:lnSpc>
             </a:pPr>
             <a:r>
-              <a:rPr sz="700" b="1" i="0" spc="500">
+              <a:rPr sz="900" b="1" i="0" spc="600">
                 <a:solidFill>
                   <a:srgbClr val="8EA0D6"/>
                 </a:solidFill>
@@ -10040,9 +10872,17 @@
           <a:prstGeom prst="roundRect">
             <a:avLst/>
           </a:prstGeom>
-          <a:solidFill>
-            <a:srgbClr val="0C1230"/>
-          </a:solidFill>
+          <a:gradFill flip="none" rotWithShape="1">
+            <a:gsLst>
+              <a:gs pos="0">
+                <a:srgbClr val="0C1230"/>
+              </a:gs>
+              <a:gs pos="100000">
+                <a:srgbClr val="04060F"/>
+              </a:gs>
+            </a:gsLst>
+            <a:lin ang="8100000" scaled="0"/>
+          </a:gradFill>
           <a:ln w="15875">
             <a:solidFill>
               <a:srgbClr val="9A7BFF"/>
@@ -10074,24 +10914,23 @@
       </p:sp>
       <p:sp>
         <p:nvSpPr>
-          <p:cNvPr id="5" name="Rounded Rectangle 4"/>
+          <p:cNvPr id="5" name="Oval 4"/>
           <p:cNvSpPr/>
           <p:nvPr/>
         </p:nvSpPr>
         <p:spPr>
           <a:xfrm>
-            <a:off x="822960" y="1097280"/>
-            <a:ext cx="3474720" cy="4663440"/>
-          </a:xfrm>
-          <a:prstGeom prst="roundRect">
-            <a:avLst/>
-          </a:prstGeom>
-          <a:noFill/>
-          <a:ln w="6350">
-            <a:solidFill>
-              <a:srgbClr val="9A7BFF"/>
-            </a:solidFill>
-            <a:prstDash val="dash"/>
+            <a:off x="182880" y="457200"/>
+            <a:ext cx="3456432" cy="3456432"/>
+          </a:xfrm>
+          <a:prstGeom prst="ellipse">
+            <a:avLst/>
+          </a:prstGeom>
+          <a:solidFill>
+            <a:srgbClr val="7C4DFF"/>
+          </a:solidFill>
+          <a:ln>
+            <a:noFill/>
           </a:ln>
           <a:effectLst/>
         </p:spPr>
@@ -10119,14 +10958,112 @@
       </p:sp>
       <p:sp>
         <p:nvSpPr>
-          <p:cNvPr id="6" name="TextBox 5"/>
+          <p:cNvPr id="6" name="Oval 5"/>
+          <p:cNvSpPr/>
+          <p:nvPr/>
+        </p:nvSpPr>
+        <p:spPr>
+          <a:xfrm>
+            <a:off x="2176272" y="3680460"/>
+            <a:ext cx="3072384" cy="3072384"/>
+          </a:xfrm>
+          <a:prstGeom prst="ellipse">
+            <a:avLst/>
+          </a:prstGeom>
+          <a:solidFill>
+            <a:srgbClr val="38E0FF"/>
+          </a:solidFill>
+          <a:ln>
+            <a:noFill/>
+          </a:ln>
+          <a:effectLst/>
+        </p:spPr>
+        <p:style>
+          <a:lnRef idx="1">
+            <a:schemeClr val="accent1"/>
+          </a:lnRef>
+          <a:fillRef idx="3">
+            <a:schemeClr val="accent1"/>
+          </a:fillRef>
+          <a:effectRef idx="2">
+            <a:schemeClr val="accent1"/>
+          </a:effectRef>
+          <a:fontRef idx="minor">
+            <a:schemeClr val="lt1"/>
+          </a:fontRef>
+        </p:style>
+        <p:txBody>
+          <a:bodyPr rtlCol="0" anchor="ctr"/>
+          <a:lstStyle/>
+          <a:p>
+            <a:pPr algn="ctr"/>
+          </a:p>
+        </p:txBody>
+      </p:sp>
+      <p:sp>
+        <p:nvSpPr>
+          <p:cNvPr id="7" name="Rounded Rectangle 6"/>
+          <p:cNvSpPr/>
+          <p:nvPr/>
+        </p:nvSpPr>
+        <p:spPr>
+          <a:xfrm>
+            <a:off x="1504188" y="1819656"/>
+            <a:ext cx="2112264" cy="2112264"/>
+          </a:xfrm>
+          <a:prstGeom prst="roundRect">
+            <a:avLst/>
+          </a:prstGeom>
+          <a:gradFill flip="none" rotWithShape="1">
+            <a:gsLst>
+              <a:gs pos="0">
+                <a:srgbClr val="121A44"/>
+              </a:gs>
+              <a:gs pos="100000">
+                <a:srgbClr val="04060F"/>
+              </a:gs>
+            </a:gsLst>
+            <a:lin ang="8100000" scaled="0"/>
+          </a:gradFill>
+          <a:ln w="19050">
+            <a:solidFill>
+              <a:srgbClr val="9A7BFF"/>
+            </a:solidFill>
+          </a:ln>
+          <a:effectLst/>
+        </p:spPr>
+        <p:style>
+          <a:lnRef idx="1">
+            <a:schemeClr val="accent1"/>
+          </a:lnRef>
+          <a:fillRef idx="3">
+            <a:schemeClr val="accent1"/>
+          </a:fillRef>
+          <a:effectRef idx="2">
+            <a:schemeClr val="accent1"/>
+          </a:effectRef>
+          <a:fontRef idx="minor">
+            <a:schemeClr val="lt1"/>
+          </a:fontRef>
+        </p:style>
+        <p:txBody>
+          <a:bodyPr rtlCol="0" anchor="ctr"/>
+          <a:lstStyle/>
+          <a:p>
+            <a:pPr algn="ctr"/>
+          </a:p>
+        </p:txBody>
+      </p:sp>
+      <p:sp>
+        <p:nvSpPr>
+          <p:cNvPr id="8" name="TextBox 7"/>
           <p:cNvSpPr txBox="1"/>
           <p:nvPr/>
         </p:nvSpPr>
         <p:spPr>
           <a:xfrm>
-            <a:off x="640080" y="3246120"/>
-            <a:ext cx="3840480" cy="365760"/>
+            <a:off x="1504188" y="1819656"/>
+            <a:ext cx="2112264" cy="2112264"/>
           </a:xfrm>
           <a:prstGeom prst="rect">
             <a:avLst/>
@@ -10145,20 +11082,181 @@
               </a:lnSpc>
             </a:pPr>
             <a:r>
-              <a:rPr sz="1000" b="1" i="0" spc="300">
-                <a:solidFill>
-                  <a:srgbClr val="8EA0D6"/>
+              <a:rPr sz="9600" b="1" i="0" spc="100">
+                <a:solidFill>
+                  <a:srgbClr val="FFFFFF"/>
                 </a:solidFill>
                 <a:latin typeface="Calibri"/>
               </a:rPr>
-              <a:t>CLOSING PORTRAIT</a:t>
-            </a:r>
-          </a:p>
-        </p:txBody>
-      </p:sp>
-      <p:sp>
-        <p:nvSpPr>
-          <p:cNvPr id="7" name="Rounded Rectangle 6"/>
+              <a:t>LH</a:t>
+            </a:r>
+          </a:p>
+        </p:txBody>
+      </p:sp>
+      <p:sp>
+        <p:nvSpPr>
+          <p:cNvPr id="9" name="Rectangle 8"/>
+          <p:cNvSpPr/>
+          <p:nvPr/>
+        </p:nvSpPr>
+        <p:spPr>
+          <a:xfrm>
+            <a:off x="2080260" y="4114800"/>
+            <a:ext cx="960120" cy="38100"/>
+          </a:xfrm>
+          <a:prstGeom prst="rect">
+            <a:avLst/>
+          </a:prstGeom>
+          <a:solidFill>
+            <a:srgbClr val="38E0FF"/>
+          </a:solidFill>
+          <a:ln>
+            <a:noFill/>
+          </a:ln>
+          <a:effectLst/>
+        </p:spPr>
+        <p:style>
+          <a:lnRef idx="1">
+            <a:schemeClr val="accent1"/>
+          </a:lnRef>
+          <a:fillRef idx="3">
+            <a:schemeClr val="accent1"/>
+          </a:fillRef>
+          <a:effectRef idx="2">
+            <a:schemeClr val="accent1"/>
+          </a:effectRef>
+          <a:fontRef idx="minor">
+            <a:schemeClr val="lt1"/>
+          </a:fontRef>
+        </p:style>
+        <p:txBody>
+          <a:bodyPr rtlCol="0" anchor="ctr"/>
+          <a:lstStyle/>
+          <a:p>
+            <a:pPr algn="ctr"/>
+          </a:p>
+        </p:txBody>
+      </p:sp>
+      <p:sp>
+        <p:nvSpPr>
+          <p:cNvPr id="10" name="TextBox 9"/>
+          <p:cNvSpPr txBox="1"/>
+          <p:nvPr/>
+        </p:nvSpPr>
+        <p:spPr>
+          <a:xfrm>
+            <a:off x="914400" y="4297680"/>
+            <a:ext cx="3291840" cy="365760"/>
+          </a:xfrm>
+          <a:prstGeom prst="rect">
+            <a:avLst/>
+          </a:prstGeom>
+          <a:noFill/>
+        </p:spPr>
+        <p:txBody>
+          <a:bodyPr wrap="square" lIns="0" rIns="0" tIns="0" bIns="0" anchor="ctr">
+            <a:spAutoFit/>
+          </a:bodyPr>
+          <a:lstStyle/>
+          <a:p>
+            <a:pPr algn="ctr">
+              <a:lnSpc>
+                <a:spcPct val="115000"/>
+              </a:lnSpc>
+            </a:pPr>
+            <a:r>
+              <a:rPr sz="1800" b="1" i="0">
+                <a:solidFill>
+                  <a:srgbClr val="FFFFFF"/>
+                </a:solidFill>
+                <a:latin typeface="Calibri"/>
+              </a:rPr>
+              <a:t>LEVEE HEDRICK</a:t>
+            </a:r>
+          </a:p>
+        </p:txBody>
+      </p:sp>
+      <p:sp>
+        <p:nvSpPr>
+          <p:cNvPr id="11" name="TextBox 10"/>
+          <p:cNvSpPr txBox="1"/>
+          <p:nvPr/>
+        </p:nvSpPr>
+        <p:spPr>
+          <a:xfrm>
+            <a:off x="914400" y="4663440"/>
+            <a:ext cx="3291840" cy="320040"/>
+          </a:xfrm>
+          <a:prstGeom prst="rect">
+            <a:avLst/>
+          </a:prstGeom>
+          <a:noFill/>
+        </p:spPr>
+        <p:txBody>
+          <a:bodyPr wrap="square" lIns="0" rIns="0" tIns="0" bIns="0" anchor="ctr">
+            <a:spAutoFit/>
+          </a:bodyPr>
+          <a:lstStyle/>
+          <a:p>
+            <a:pPr algn="ctr">
+              <a:lnSpc>
+                <a:spcPct val="115000"/>
+              </a:lnSpc>
+            </a:pPr>
+            <a:r>
+              <a:rPr sz="900" b="1" i="0" spc="400">
+                <a:solidFill>
+                  <a:srgbClr val="7EF0FF"/>
+                </a:solidFill>
+                <a:latin typeface="Calibri"/>
+              </a:rPr>
+              <a:t>MATERIAL CONTROL MANAGER</a:t>
+            </a:r>
+          </a:p>
+        </p:txBody>
+      </p:sp>
+      <p:sp>
+        <p:nvSpPr>
+          <p:cNvPr id="12" name="TextBox 11"/>
+          <p:cNvSpPr txBox="1"/>
+          <p:nvPr/>
+        </p:nvSpPr>
+        <p:spPr>
+          <a:xfrm>
+            <a:off x="914400" y="5029200"/>
+            <a:ext cx="3291840" cy="274320"/>
+          </a:xfrm>
+          <a:prstGeom prst="rect">
+            <a:avLst/>
+          </a:prstGeom>
+          <a:noFill/>
+        </p:spPr>
+        <p:txBody>
+          <a:bodyPr wrap="square" lIns="0" rIns="0" tIns="0" bIns="0" anchor="ctr">
+            <a:spAutoFit/>
+          </a:bodyPr>
+          <a:lstStyle/>
+          <a:p>
+            <a:pPr algn="ctr">
+              <a:lnSpc>
+                <a:spcPct val="115000"/>
+              </a:lnSpc>
+            </a:pPr>
+            <a:r>
+              <a:rPr sz="800" b="0" i="1" spc="300">
+                <a:solidFill>
+                  <a:srgbClr val="8EA0D6"/>
+                </a:solidFill>
+                <a:latin typeface="Calibri"/>
+              </a:rPr>
+              <a:t>Accutite Fasteners, Inc.</a:t>
+            </a:r>
+          </a:p>
+        </p:txBody>
+      </p:sp>
+      <p:sp>
+        <p:nvSpPr>
+          <p:cNvPr id="13" name="Rounded Rectangle 12"/>
           <p:cNvSpPr/>
           <p:nvPr/>
         </p:nvSpPr>
@@ -10206,7 +11304,7 @@
       </p:sp>
       <p:sp>
         <p:nvSpPr>
-          <p:cNvPr id="8" name="TextBox 7"/>
+          <p:cNvPr id="14" name="TextBox 13"/>
           <p:cNvSpPr txBox="1"/>
           <p:nvPr/>
         </p:nvSpPr>
@@ -10245,7 +11343,7 @@
       </p:sp>
       <p:sp>
         <p:nvSpPr>
-          <p:cNvPr id="9" name="TextBox 8"/>
+          <p:cNvPr id="15" name="TextBox 14"/>
           <p:cNvSpPr txBox="1"/>
           <p:nvPr/>
         </p:nvSpPr>
@@ -10284,7 +11382,7 @@
       </p:sp>
       <p:sp>
         <p:nvSpPr>
-          <p:cNvPr id="10" name="TextBox 9"/>
+          <p:cNvPr id="16" name="TextBox 15"/>
           <p:cNvSpPr txBox="1"/>
           <p:nvPr/>
         </p:nvSpPr>
@@ -10323,7 +11421,7 @@
       </p:sp>
       <p:sp>
         <p:nvSpPr>
-          <p:cNvPr id="11" name="Rectangle 10"/>
+          <p:cNvPr id="17" name="Rectangle 16"/>
           <p:cNvSpPr/>
           <p:nvPr/>
         </p:nvSpPr>
@@ -10367,7 +11465,7 @@
       </p:sp>
       <p:sp>
         <p:nvSpPr>
-          <p:cNvPr id="12" name="Rounded Rectangle 11"/>
+          <p:cNvPr id="18" name="Rounded Rectangle 17"/>
           <p:cNvSpPr/>
           <p:nvPr/>
         </p:nvSpPr>
@@ -10413,7 +11511,7 @@
       </p:sp>
       <p:sp>
         <p:nvSpPr>
-          <p:cNvPr id="13" name="TextBox 12"/>
+          <p:cNvPr id="19" name="TextBox 18"/>
           <p:cNvSpPr txBox="1"/>
           <p:nvPr/>
         </p:nvSpPr>
@@ -10452,7 +11550,7 @@
       </p:sp>
       <p:sp>
         <p:nvSpPr>
-          <p:cNvPr id="14" name="TextBox 13"/>
+          <p:cNvPr id="20" name="TextBox 19"/>
           <p:cNvSpPr txBox="1"/>
           <p:nvPr/>
         </p:nvSpPr>
@@ -10491,7 +11589,7 @@
       </p:sp>
       <p:sp>
         <p:nvSpPr>
-          <p:cNvPr id="15" name="TextBox 14"/>
+          <p:cNvPr id="21" name="TextBox 20"/>
           <p:cNvSpPr txBox="1"/>
           <p:nvPr/>
         </p:nvSpPr>
@@ -10530,7 +11628,7 @@
       </p:sp>
       <p:sp>
         <p:nvSpPr>
-          <p:cNvPr id="16" name="TextBox 15"/>
+          <p:cNvPr id="22" name="TextBox 21"/>
           <p:cNvSpPr txBox="1"/>
           <p:nvPr/>
         </p:nvSpPr>
@@ -10569,7 +11667,7 @@
       </p:sp>
       <p:sp>
         <p:nvSpPr>
-          <p:cNvPr id="17" name="TextBox 16"/>
+          <p:cNvPr id="23" name="TextBox 22"/>
           <p:cNvSpPr txBox="1"/>
           <p:nvPr/>
         </p:nvSpPr>
@@ -10608,7 +11706,7 @@
       </p:sp>
       <p:sp>
         <p:nvSpPr>
-          <p:cNvPr id="18" name="TextBox 17"/>
+          <p:cNvPr id="24" name="TextBox 23"/>
           <p:cNvSpPr txBox="1"/>
           <p:nvPr/>
         </p:nvSpPr>
@@ -10647,25 +11745,31 @@
       </p:sp>
       <p:sp>
         <p:nvSpPr>
-          <p:cNvPr id="19" name="Rounded Rectangle 18"/>
+          <p:cNvPr id="25" name="Block Arc 24"/>
           <p:cNvSpPr/>
           <p:nvPr/>
         </p:nvSpPr>
         <p:spPr>
           <a:xfrm>
-            <a:off x="9784080" y="6035040"/>
-            <a:ext cx="2194560" cy="640080"/>
-          </a:xfrm>
-          <a:prstGeom prst="roundRect">
-            <a:avLst/>
-          </a:prstGeom>
-          <a:solidFill>
-            <a:srgbClr val="0C1230"/>
-          </a:solidFill>
-          <a:ln w="9525">
-            <a:solidFill>
-              <a:srgbClr val="9A7BFF"/>
-            </a:solidFill>
+            <a:off x="10277856" y="6080760"/>
+            <a:ext cx="1207008" cy="603504"/>
+          </a:xfrm>
+          <a:prstGeom prst="blockArc">
+            <a:avLst/>
+          </a:prstGeom>
+          <a:gradFill flip="none" rotWithShape="1">
+            <a:gsLst>
+              <a:gs pos="0">
+                <a:srgbClr val="38E0FF"/>
+              </a:gs>
+              <a:gs pos="100000">
+                <a:srgbClr val="7C4DFF"/>
+              </a:gs>
+            </a:gsLst>
+            <a:lin ang="0" scaled="0"/>
+          </a:gradFill>
+          <a:ln>
+            <a:noFill/>
           </a:ln>
           <a:effectLst/>
         </p:spPr>
@@ -10693,14 +11797,58 @@
       </p:sp>
       <p:sp>
         <p:nvSpPr>
-          <p:cNvPr id="20" name="TextBox 19"/>
+          <p:cNvPr id="26" name="Diamond 25"/>
+          <p:cNvSpPr/>
+          <p:nvPr/>
+        </p:nvSpPr>
+        <p:spPr>
+          <a:xfrm>
+            <a:off x="11424513" y="6171285"/>
+            <a:ext cx="132770" cy="132770"/>
+          </a:xfrm>
+          <a:prstGeom prst="diamond">
+            <a:avLst/>
+          </a:prstGeom>
+          <a:solidFill>
+            <a:srgbClr val="38E0FF"/>
+          </a:solidFill>
+          <a:ln>
+            <a:noFill/>
+          </a:ln>
+          <a:effectLst/>
+        </p:spPr>
+        <p:style>
+          <a:lnRef idx="1">
+            <a:schemeClr val="accent1"/>
+          </a:lnRef>
+          <a:fillRef idx="3">
+            <a:schemeClr val="accent1"/>
+          </a:fillRef>
+          <a:effectRef idx="2">
+            <a:schemeClr val="accent1"/>
+          </a:effectRef>
+          <a:fontRef idx="minor">
+            <a:schemeClr val="lt1"/>
+          </a:fontRef>
+        </p:style>
+        <p:txBody>
+          <a:bodyPr rtlCol="0" anchor="ctr"/>
+          <a:lstStyle/>
+          <a:p>
+            <a:pPr algn="ctr"/>
+          </a:p>
+        </p:txBody>
+      </p:sp>
+      <p:sp>
+        <p:nvSpPr>
+          <p:cNvPr id="27" name="TextBox 26"/>
           <p:cNvSpPr txBox="1"/>
           <p:nvPr/>
         </p:nvSpPr>
         <p:spPr>
           <a:xfrm>
-            <a:off x="9784080" y="6060440"/>
-            <a:ext cx="2194560" cy="320040"/>
+            <a:off x="9784080" y="6729984"/>
+            <a:ext cx="2194560" cy="310896"/>
           </a:xfrm>
           <a:prstGeom prst="rect">
             <a:avLst/>
@@ -10719,7 +11867,7 @@
               </a:lnSpc>
             </a:pPr>
             <a:r>
-              <a:rPr sz="1400" b="1" i="0" spc="400">
+              <a:rPr sz="1800" b="1" i="0" spc="450">
                 <a:solidFill>
                   <a:srgbClr val="FFFFFF"/>
                 </a:solidFill>
@@ -10732,14 +11880,14 @@
       </p:sp>
       <p:sp>
         <p:nvSpPr>
-          <p:cNvPr id="21" name="TextBox 20"/>
+          <p:cNvPr id="28" name="TextBox 27"/>
           <p:cNvSpPr txBox="1"/>
           <p:nvPr/>
         </p:nvSpPr>
         <p:spPr>
           <a:xfrm>
-            <a:off x="9784080" y="6355080"/>
-            <a:ext cx="2194560" cy="320040"/>
+            <a:off x="9784080" y="7040880"/>
+            <a:ext cx="2194560" cy="201168"/>
           </a:xfrm>
           <a:prstGeom prst="rect">
             <a:avLst/>
@@ -10758,7 +11906,7 @@
               </a:lnSpc>
             </a:pPr>
             <a:r>
-              <a:rPr sz="800" b="1" i="0" spc="500">
+              <a:rPr sz="900" b="1" i="0" spc="600">
                 <a:solidFill>
                   <a:srgbClr val="8EA0D6"/>
                 </a:solidFill>
@@ -10771,7 +11919,7 @@
       </p:sp>
       <p:sp>
         <p:nvSpPr>
-          <p:cNvPr id="22" name="TextBox 21"/>
+          <p:cNvPr id="29" name="TextBox 28"/>
           <p:cNvSpPr txBox="1"/>
           <p:nvPr/>
         </p:nvSpPr>
@@ -11650,25 +12798,31 @@
       </p:sp>
       <p:sp>
         <p:nvSpPr>
-          <p:cNvPr id="21" name="Rounded Rectangle 20"/>
+          <p:cNvPr id="21" name="Block Arc 20"/>
           <p:cNvSpPr/>
           <p:nvPr/>
         </p:nvSpPr>
         <p:spPr>
           <a:xfrm>
-            <a:off x="10241280" y="320040"/>
-            <a:ext cx="1645920" cy="502920"/>
-          </a:xfrm>
-          <a:prstGeom prst="roundRect">
-            <a:avLst/>
-          </a:prstGeom>
-          <a:solidFill>
-            <a:srgbClr val="0C1230"/>
-          </a:solidFill>
-          <a:ln w="9525">
-            <a:solidFill>
-              <a:srgbClr val="9A7BFF"/>
-            </a:solidFill>
+            <a:off x="10611612" y="365760"/>
+            <a:ext cx="905256" cy="452628"/>
+          </a:xfrm>
+          <a:prstGeom prst="blockArc">
+            <a:avLst/>
+          </a:prstGeom>
+          <a:gradFill flip="none" rotWithShape="1">
+            <a:gsLst>
+              <a:gs pos="0">
+                <a:srgbClr val="38E0FF"/>
+              </a:gs>
+              <a:gs pos="100000">
+                <a:srgbClr val="7C4DFF"/>
+              </a:gs>
+            </a:gsLst>
+            <a:lin ang="0" scaled="0"/>
+          </a:gradFill>
+          <a:ln>
+            <a:noFill/>
           </a:ln>
           <a:effectLst/>
         </p:spPr>
@@ -11696,14 +12850,58 @@
       </p:sp>
       <p:sp>
         <p:nvSpPr>
-          <p:cNvPr id="22" name="TextBox 21"/>
+          <p:cNvPr id="22" name="Diamond 21"/>
+          <p:cNvSpPr/>
+          <p:nvPr/>
+        </p:nvSpPr>
+        <p:spPr>
+          <a:xfrm>
+            <a:off x="11471605" y="433654"/>
+            <a:ext cx="99578" cy="99578"/>
+          </a:xfrm>
+          <a:prstGeom prst="diamond">
+            <a:avLst/>
+          </a:prstGeom>
+          <a:solidFill>
+            <a:srgbClr val="38E0FF"/>
+          </a:solidFill>
+          <a:ln>
+            <a:noFill/>
+          </a:ln>
+          <a:effectLst/>
+        </p:spPr>
+        <p:style>
+          <a:lnRef idx="1">
+            <a:schemeClr val="accent1"/>
+          </a:lnRef>
+          <a:fillRef idx="3">
+            <a:schemeClr val="accent1"/>
+          </a:fillRef>
+          <a:effectRef idx="2">
+            <a:schemeClr val="accent1"/>
+          </a:effectRef>
+          <a:fontRef idx="minor">
+            <a:schemeClr val="lt1"/>
+          </a:fontRef>
+        </p:style>
+        <p:txBody>
+          <a:bodyPr rtlCol="0" anchor="ctr"/>
+          <a:lstStyle/>
+          <a:p>
+            <a:pPr algn="ctr"/>
+          </a:p>
+        </p:txBody>
+      </p:sp>
+      <p:sp>
+        <p:nvSpPr>
+          <p:cNvPr id="23" name="TextBox 22"/>
           <p:cNvSpPr txBox="1"/>
           <p:nvPr/>
         </p:nvSpPr>
         <p:spPr>
           <a:xfrm>
-            <a:off x="10241280" y="345440"/>
-            <a:ext cx="1645920" cy="251460"/>
+            <a:off x="10241280" y="864108"/>
+            <a:ext cx="1645920" cy="310896"/>
           </a:xfrm>
           <a:prstGeom prst="rect">
             <a:avLst/>
@@ -11722,7 +12920,7 @@
               </a:lnSpc>
             </a:pPr>
             <a:r>
-              <a:rPr sz="1100" b="1" i="0" spc="400">
+              <a:rPr sz="1800" b="1" i="0" spc="450">
                 <a:solidFill>
                   <a:srgbClr val="FFFFFF"/>
                 </a:solidFill>
@@ -11735,14 +12933,14 @@
       </p:sp>
       <p:sp>
         <p:nvSpPr>
-          <p:cNvPr id="23" name="TextBox 22"/>
+          <p:cNvPr id="24" name="TextBox 23"/>
           <p:cNvSpPr txBox="1"/>
           <p:nvPr/>
         </p:nvSpPr>
         <p:spPr>
           <a:xfrm>
-            <a:off x="10241280" y="571500"/>
-            <a:ext cx="1645920" cy="251460"/>
+            <a:off x="10241280" y="1175004"/>
+            <a:ext cx="1645920" cy="201168"/>
           </a:xfrm>
           <a:prstGeom prst="rect">
             <a:avLst/>
@@ -11761,7 +12959,7 @@
               </a:lnSpc>
             </a:pPr>
             <a:r>
-              <a:rPr sz="700" b="1" i="0" spc="500">
+              <a:rPr sz="900" b="1" i="0" spc="600">
                 <a:solidFill>
                   <a:srgbClr val="8EA0D6"/>
                 </a:solidFill>
@@ -12614,25 +13812,31 @@
       </p:sp>
       <p:sp>
         <p:nvSpPr>
-          <p:cNvPr id="21" name="Rounded Rectangle 20"/>
+          <p:cNvPr id="21" name="Block Arc 20"/>
           <p:cNvSpPr/>
           <p:nvPr/>
         </p:nvSpPr>
         <p:spPr>
           <a:xfrm>
-            <a:off x="10241280" y="320040"/>
-            <a:ext cx="1645920" cy="502920"/>
-          </a:xfrm>
-          <a:prstGeom prst="roundRect">
-            <a:avLst/>
-          </a:prstGeom>
-          <a:solidFill>
-            <a:srgbClr val="0C1230"/>
-          </a:solidFill>
-          <a:ln w="9525">
-            <a:solidFill>
-              <a:srgbClr val="9A7BFF"/>
-            </a:solidFill>
+            <a:off x="10611612" y="365760"/>
+            <a:ext cx="905256" cy="452628"/>
+          </a:xfrm>
+          <a:prstGeom prst="blockArc">
+            <a:avLst/>
+          </a:prstGeom>
+          <a:gradFill flip="none" rotWithShape="1">
+            <a:gsLst>
+              <a:gs pos="0">
+                <a:srgbClr val="38E0FF"/>
+              </a:gs>
+              <a:gs pos="100000">
+                <a:srgbClr val="7C4DFF"/>
+              </a:gs>
+            </a:gsLst>
+            <a:lin ang="0" scaled="0"/>
+          </a:gradFill>
+          <a:ln>
+            <a:noFill/>
           </a:ln>
           <a:effectLst/>
         </p:spPr>
@@ -12660,14 +13864,58 @@
       </p:sp>
       <p:sp>
         <p:nvSpPr>
-          <p:cNvPr id="22" name="TextBox 21"/>
+          <p:cNvPr id="22" name="Diamond 21"/>
+          <p:cNvSpPr/>
+          <p:nvPr/>
+        </p:nvSpPr>
+        <p:spPr>
+          <a:xfrm>
+            <a:off x="11471605" y="433654"/>
+            <a:ext cx="99578" cy="99578"/>
+          </a:xfrm>
+          <a:prstGeom prst="diamond">
+            <a:avLst/>
+          </a:prstGeom>
+          <a:solidFill>
+            <a:srgbClr val="38E0FF"/>
+          </a:solidFill>
+          <a:ln>
+            <a:noFill/>
+          </a:ln>
+          <a:effectLst/>
+        </p:spPr>
+        <p:style>
+          <a:lnRef idx="1">
+            <a:schemeClr val="accent1"/>
+          </a:lnRef>
+          <a:fillRef idx="3">
+            <a:schemeClr val="accent1"/>
+          </a:fillRef>
+          <a:effectRef idx="2">
+            <a:schemeClr val="accent1"/>
+          </a:effectRef>
+          <a:fontRef idx="minor">
+            <a:schemeClr val="lt1"/>
+          </a:fontRef>
+        </p:style>
+        <p:txBody>
+          <a:bodyPr rtlCol="0" anchor="ctr"/>
+          <a:lstStyle/>
+          <a:p>
+            <a:pPr algn="ctr"/>
+          </a:p>
+        </p:txBody>
+      </p:sp>
+      <p:sp>
+        <p:nvSpPr>
+          <p:cNvPr id="23" name="TextBox 22"/>
           <p:cNvSpPr txBox="1"/>
           <p:nvPr/>
         </p:nvSpPr>
         <p:spPr>
           <a:xfrm>
-            <a:off x="10241280" y="345440"/>
-            <a:ext cx="1645920" cy="251460"/>
+            <a:off x="10241280" y="864108"/>
+            <a:ext cx="1645920" cy="310896"/>
           </a:xfrm>
           <a:prstGeom prst="rect">
             <a:avLst/>
@@ -12686,7 +13934,7 @@
               </a:lnSpc>
             </a:pPr>
             <a:r>
-              <a:rPr sz="1100" b="1" i="0" spc="400">
+              <a:rPr sz="1800" b="1" i="0" spc="450">
                 <a:solidFill>
                   <a:srgbClr val="FFFFFF"/>
                 </a:solidFill>
@@ -12699,14 +13947,14 @@
       </p:sp>
       <p:sp>
         <p:nvSpPr>
-          <p:cNvPr id="23" name="TextBox 22"/>
+          <p:cNvPr id="24" name="TextBox 23"/>
           <p:cNvSpPr txBox="1"/>
           <p:nvPr/>
         </p:nvSpPr>
         <p:spPr>
           <a:xfrm>
-            <a:off x="10241280" y="571500"/>
-            <a:ext cx="1645920" cy="251460"/>
+            <a:off x="10241280" y="1175004"/>
+            <a:ext cx="1645920" cy="201168"/>
           </a:xfrm>
           <a:prstGeom prst="rect">
             <a:avLst/>
@@ -12725,7 +13973,7 @@
               </a:lnSpc>
             </a:pPr>
             <a:r>
-              <a:rPr sz="700" b="1" i="0" spc="500">
+              <a:rPr sz="900" b="1" i="0" spc="600">
                 <a:solidFill>
                   <a:srgbClr val="8EA0D6"/>
                 </a:solidFill>
@@ -13800,25 +15048,31 @@
       </p:sp>
       <p:sp>
         <p:nvSpPr>
-          <p:cNvPr id="26" name="Rounded Rectangle 25"/>
+          <p:cNvPr id="26" name="Block Arc 25"/>
           <p:cNvSpPr/>
           <p:nvPr/>
         </p:nvSpPr>
         <p:spPr>
           <a:xfrm>
-            <a:off x="10241280" y="320040"/>
-            <a:ext cx="1645920" cy="502920"/>
-          </a:xfrm>
-          <a:prstGeom prst="roundRect">
-            <a:avLst/>
-          </a:prstGeom>
-          <a:solidFill>
-            <a:srgbClr val="0C1230"/>
-          </a:solidFill>
-          <a:ln w="9525">
-            <a:solidFill>
-              <a:srgbClr val="9A7BFF"/>
-            </a:solidFill>
+            <a:off x="10611612" y="365760"/>
+            <a:ext cx="905256" cy="452628"/>
+          </a:xfrm>
+          <a:prstGeom prst="blockArc">
+            <a:avLst/>
+          </a:prstGeom>
+          <a:gradFill flip="none" rotWithShape="1">
+            <a:gsLst>
+              <a:gs pos="0">
+                <a:srgbClr val="38E0FF"/>
+              </a:gs>
+              <a:gs pos="100000">
+                <a:srgbClr val="7C4DFF"/>
+              </a:gs>
+            </a:gsLst>
+            <a:lin ang="0" scaled="0"/>
+          </a:gradFill>
+          <a:ln>
+            <a:noFill/>
           </a:ln>
           <a:effectLst/>
         </p:spPr>
@@ -13846,14 +15100,58 @@
       </p:sp>
       <p:sp>
         <p:nvSpPr>
-          <p:cNvPr id="27" name="TextBox 26"/>
+          <p:cNvPr id="27" name="Diamond 26"/>
+          <p:cNvSpPr/>
+          <p:nvPr/>
+        </p:nvSpPr>
+        <p:spPr>
+          <a:xfrm>
+            <a:off x="11471605" y="433654"/>
+            <a:ext cx="99578" cy="99578"/>
+          </a:xfrm>
+          <a:prstGeom prst="diamond">
+            <a:avLst/>
+          </a:prstGeom>
+          <a:solidFill>
+            <a:srgbClr val="38E0FF"/>
+          </a:solidFill>
+          <a:ln>
+            <a:noFill/>
+          </a:ln>
+          <a:effectLst/>
+        </p:spPr>
+        <p:style>
+          <a:lnRef idx="1">
+            <a:schemeClr val="accent1"/>
+          </a:lnRef>
+          <a:fillRef idx="3">
+            <a:schemeClr val="accent1"/>
+          </a:fillRef>
+          <a:effectRef idx="2">
+            <a:schemeClr val="accent1"/>
+          </a:effectRef>
+          <a:fontRef idx="minor">
+            <a:schemeClr val="lt1"/>
+          </a:fontRef>
+        </p:style>
+        <p:txBody>
+          <a:bodyPr rtlCol="0" anchor="ctr"/>
+          <a:lstStyle/>
+          <a:p>
+            <a:pPr algn="ctr"/>
+          </a:p>
+        </p:txBody>
+      </p:sp>
+      <p:sp>
+        <p:nvSpPr>
+          <p:cNvPr id="28" name="TextBox 27"/>
           <p:cNvSpPr txBox="1"/>
           <p:nvPr/>
         </p:nvSpPr>
         <p:spPr>
           <a:xfrm>
-            <a:off x="10241280" y="345440"/>
-            <a:ext cx="1645920" cy="251460"/>
+            <a:off x="10241280" y="864108"/>
+            <a:ext cx="1645920" cy="310896"/>
           </a:xfrm>
           <a:prstGeom prst="rect">
             <a:avLst/>
@@ -13872,7 +15170,7 @@
               </a:lnSpc>
             </a:pPr>
             <a:r>
-              <a:rPr sz="1100" b="1" i="0" spc="400">
+              <a:rPr sz="1800" b="1" i="0" spc="450">
                 <a:solidFill>
                   <a:srgbClr val="FFFFFF"/>
                 </a:solidFill>
@@ -13885,14 +15183,14 @@
       </p:sp>
       <p:sp>
         <p:nvSpPr>
-          <p:cNvPr id="28" name="TextBox 27"/>
+          <p:cNvPr id="29" name="TextBox 28"/>
           <p:cNvSpPr txBox="1"/>
           <p:nvPr/>
         </p:nvSpPr>
         <p:spPr>
           <a:xfrm>
-            <a:off x="10241280" y="571500"/>
-            <a:ext cx="1645920" cy="251460"/>
+            <a:off x="10241280" y="1175004"/>
+            <a:ext cx="1645920" cy="201168"/>
           </a:xfrm>
           <a:prstGeom prst="rect">
             <a:avLst/>
@@ -13911,7 +15209,7 @@
               </a:lnSpc>
             </a:pPr>
             <a:r>
-              <a:rPr sz="700" b="1" i="0" spc="500">
+              <a:rPr sz="900" b="1" i="0" spc="600">
                 <a:solidFill>
                   <a:srgbClr val="8EA0D6"/>
                 </a:solidFill>
@@ -15049,25 +16347,31 @@
       </p:sp>
       <p:sp>
         <p:nvSpPr>
-          <p:cNvPr id="28" name="Rounded Rectangle 27"/>
+          <p:cNvPr id="28" name="Block Arc 27"/>
           <p:cNvSpPr/>
           <p:nvPr/>
         </p:nvSpPr>
         <p:spPr>
           <a:xfrm>
-            <a:off x="10241280" y="320040"/>
-            <a:ext cx="1645920" cy="502920"/>
-          </a:xfrm>
-          <a:prstGeom prst="roundRect">
-            <a:avLst/>
-          </a:prstGeom>
-          <a:solidFill>
-            <a:srgbClr val="0C1230"/>
-          </a:solidFill>
-          <a:ln w="9525">
-            <a:solidFill>
-              <a:srgbClr val="9A7BFF"/>
-            </a:solidFill>
+            <a:off x="10611612" y="365760"/>
+            <a:ext cx="905256" cy="452628"/>
+          </a:xfrm>
+          <a:prstGeom prst="blockArc">
+            <a:avLst/>
+          </a:prstGeom>
+          <a:gradFill flip="none" rotWithShape="1">
+            <a:gsLst>
+              <a:gs pos="0">
+                <a:srgbClr val="38E0FF"/>
+              </a:gs>
+              <a:gs pos="100000">
+                <a:srgbClr val="7C4DFF"/>
+              </a:gs>
+            </a:gsLst>
+            <a:lin ang="0" scaled="0"/>
+          </a:gradFill>
+          <a:ln>
+            <a:noFill/>
           </a:ln>
           <a:effectLst/>
         </p:spPr>
@@ -15095,14 +16399,58 @@
       </p:sp>
       <p:sp>
         <p:nvSpPr>
-          <p:cNvPr id="29" name="TextBox 28"/>
+          <p:cNvPr id="29" name="Diamond 28"/>
+          <p:cNvSpPr/>
+          <p:nvPr/>
+        </p:nvSpPr>
+        <p:spPr>
+          <a:xfrm>
+            <a:off x="11471605" y="433654"/>
+            <a:ext cx="99578" cy="99578"/>
+          </a:xfrm>
+          <a:prstGeom prst="diamond">
+            <a:avLst/>
+          </a:prstGeom>
+          <a:solidFill>
+            <a:srgbClr val="38E0FF"/>
+          </a:solidFill>
+          <a:ln>
+            <a:noFill/>
+          </a:ln>
+          <a:effectLst/>
+        </p:spPr>
+        <p:style>
+          <a:lnRef idx="1">
+            <a:schemeClr val="accent1"/>
+          </a:lnRef>
+          <a:fillRef idx="3">
+            <a:schemeClr val="accent1"/>
+          </a:fillRef>
+          <a:effectRef idx="2">
+            <a:schemeClr val="accent1"/>
+          </a:effectRef>
+          <a:fontRef idx="minor">
+            <a:schemeClr val="lt1"/>
+          </a:fontRef>
+        </p:style>
+        <p:txBody>
+          <a:bodyPr rtlCol="0" anchor="ctr"/>
+          <a:lstStyle/>
+          <a:p>
+            <a:pPr algn="ctr"/>
+          </a:p>
+        </p:txBody>
+      </p:sp>
+      <p:sp>
+        <p:nvSpPr>
+          <p:cNvPr id="30" name="TextBox 29"/>
           <p:cNvSpPr txBox="1"/>
           <p:nvPr/>
         </p:nvSpPr>
         <p:spPr>
           <a:xfrm>
-            <a:off x="10241280" y="345440"/>
-            <a:ext cx="1645920" cy="251460"/>
+            <a:off x="10241280" y="864108"/>
+            <a:ext cx="1645920" cy="310896"/>
           </a:xfrm>
           <a:prstGeom prst="rect">
             <a:avLst/>
@@ -15121,7 +16469,7 @@
               </a:lnSpc>
             </a:pPr>
             <a:r>
-              <a:rPr sz="1100" b="1" i="0" spc="400">
+              <a:rPr sz="1800" b="1" i="0" spc="450">
                 <a:solidFill>
                   <a:srgbClr val="FFFFFF"/>
                 </a:solidFill>
@@ -15134,14 +16482,14 @@
       </p:sp>
       <p:sp>
         <p:nvSpPr>
-          <p:cNvPr id="30" name="TextBox 29"/>
+          <p:cNvPr id="31" name="TextBox 30"/>
           <p:cNvSpPr txBox="1"/>
           <p:nvPr/>
         </p:nvSpPr>
         <p:spPr>
           <a:xfrm>
-            <a:off x="10241280" y="571500"/>
-            <a:ext cx="1645920" cy="251460"/>
+            <a:off x="10241280" y="1175004"/>
+            <a:ext cx="1645920" cy="201168"/>
           </a:xfrm>
           <a:prstGeom prst="rect">
             <a:avLst/>
@@ -15160,7 +16508,7 @@
               </a:lnSpc>
             </a:pPr>
             <a:r>
-              <a:rPr sz="700" b="1" i="0" spc="500">
+              <a:rPr sz="900" b="1" i="0" spc="600">
                 <a:solidFill>
                   <a:srgbClr val="8EA0D6"/>
                 </a:solidFill>
@@ -16298,25 +17646,31 @@
       </p:sp>
       <p:sp>
         <p:nvSpPr>
-          <p:cNvPr id="28" name="Rounded Rectangle 27"/>
+          <p:cNvPr id="28" name="Block Arc 27"/>
           <p:cNvSpPr/>
           <p:nvPr/>
         </p:nvSpPr>
         <p:spPr>
           <a:xfrm>
-            <a:off x="10241280" y="320040"/>
-            <a:ext cx="1645920" cy="502920"/>
-          </a:xfrm>
-          <a:prstGeom prst="roundRect">
-            <a:avLst/>
-          </a:prstGeom>
-          <a:solidFill>
-            <a:srgbClr val="0C1230"/>
-          </a:solidFill>
-          <a:ln w="9525">
-            <a:solidFill>
-              <a:srgbClr val="9A7BFF"/>
-            </a:solidFill>
+            <a:off x="10611612" y="365760"/>
+            <a:ext cx="905256" cy="452628"/>
+          </a:xfrm>
+          <a:prstGeom prst="blockArc">
+            <a:avLst/>
+          </a:prstGeom>
+          <a:gradFill flip="none" rotWithShape="1">
+            <a:gsLst>
+              <a:gs pos="0">
+                <a:srgbClr val="38E0FF"/>
+              </a:gs>
+              <a:gs pos="100000">
+                <a:srgbClr val="7C4DFF"/>
+              </a:gs>
+            </a:gsLst>
+            <a:lin ang="0" scaled="0"/>
+          </a:gradFill>
+          <a:ln>
+            <a:noFill/>
           </a:ln>
           <a:effectLst/>
         </p:spPr>
@@ -16344,14 +17698,58 @@
       </p:sp>
       <p:sp>
         <p:nvSpPr>
-          <p:cNvPr id="29" name="TextBox 28"/>
+          <p:cNvPr id="29" name="Diamond 28"/>
+          <p:cNvSpPr/>
+          <p:nvPr/>
+        </p:nvSpPr>
+        <p:spPr>
+          <a:xfrm>
+            <a:off x="11471605" y="433654"/>
+            <a:ext cx="99578" cy="99578"/>
+          </a:xfrm>
+          <a:prstGeom prst="diamond">
+            <a:avLst/>
+          </a:prstGeom>
+          <a:solidFill>
+            <a:srgbClr val="38E0FF"/>
+          </a:solidFill>
+          <a:ln>
+            <a:noFill/>
+          </a:ln>
+          <a:effectLst/>
+        </p:spPr>
+        <p:style>
+          <a:lnRef idx="1">
+            <a:schemeClr val="accent1"/>
+          </a:lnRef>
+          <a:fillRef idx="3">
+            <a:schemeClr val="accent1"/>
+          </a:fillRef>
+          <a:effectRef idx="2">
+            <a:schemeClr val="accent1"/>
+          </a:effectRef>
+          <a:fontRef idx="minor">
+            <a:schemeClr val="lt1"/>
+          </a:fontRef>
+        </p:style>
+        <p:txBody>
+          <a:bodyPr rtlCol="0" anchor="ctr"/>
+          <a:lstStyle/>
+          <a:p>
+            <a:pPr algn="ctr"/>
+          </a:p>
+        </p:txBody>
+      </p:sp>
+      <p:sp>
+        <p:nvSpPr>
+          <p:cNvPr id="30" name="TextBox 29"/>
           <p:cNvSpPr txBox="1"/>
           <p:nvPr/>
         </p:nvSpPr>
         <p:spPr>
           <a:xfrm>
-            <a:off x="10241280" y="345440"/>
-            <a:ext cx="1645920" cy="251460"/>
+            <a:off x="10241280" y="864108"/>
+            <a:ext cx="1645920" cy="310896"/>
           </a:xfrm>
           <a:prstGeom prst="rect">
             <a:avLst/>
@@ -16370,7 +17768,7 @@
               </a:lnSpc>
             </a:pPr>
             <a:r>
-              <a:rPr sz="1100" b="1" i="0" spc="400">
+              <a:rPr sz="1800" b="1" i="0" spc="450">
                 <a:solidFill>
                   <a:srgbClr val="FFFFFF"/>
                 </a:solidFill>
@@ -16383,14 +17781,14 @@
       </p:sp>
       <p:sp>
         <p:nvSpPr>
-          <p:cNvPr id="30" name="TextBox 29"/>
+          <p:cNvPr id="31" name="TextBox 30"/>
           <p:cNvSpPr txBox="1"/>
           <p:nvPr/>
         </p:nvSpPr>
         <p:spPr>
           <a:xfrm>
-            <a:off x="10241280" y="571500"/>
-            <a:ext cx="1645920" cy="251460"/>
+            <a:off x="10241280" y="1175004"/>
+            <a:ext cx="1645920" cy="201168"/>
           </a:xfrm>
           <a:prstGeom prst="rect">
             <a:avLst/>
@@ -16409,7 +17807,7 @@
               </a:lnSpc>
             </a:pPr>
             <a:r>
-              <a:rPr sz="700" b="1" i="0" spc="500">
+              <a:rPr sz="900" b="1" i="0" spc="600">
                 <a:solidFill>
                   <a:srgbClr val="8EA0D6"/>
                 </a:solidFill>
@@ -17391,25 +18789,31 @@
       </p:sp>
       <p:sp>
         <p:nvSpPr>
-          <p:cNvPr id="24" name="Rounded Rectangle 23"/>
+          <p:cNvPr id="24" name="Block Arc 23"/>
           <p:cNvSpPr/>
           <p:nvPr/>
         </p:nvSpPr>
         <p:spPr>
           <a:xfrm>
-            <a:off x="10241280" y="320040"/>
-            <a:ext cx="1645920" cy="502920"/>
-          </a:xfrm>
-          <a:prstGeom prst="roundRect">
-            <a:avLst/>
-          </a:prstGeom>
-          <a:solidFill>
-            <a:srgbClr val="0C1230"/>
-          </a:solidFill>
-          <a:ln w="9525">
-            <a:solidFill>
-              <a:srgbClr val="9A7BFF"/>
-            </a:solidFill>
+            <a:off x="10611612" y="365760"/>
+            <a:ext cx="905256" cy="452628"/>
+          </a:xfrm>
+          <a:prstGeom prst="blockArc">
+            <a:avLst/>
+          </a:prstGeom>
+          <a:gradFill flip="none" rotWithShape="1">
+            <a:gsLst>
+              <a:gs pos="0">
+                <a:srgbClr val="38E0FF"/>
+              </a:gs>
+              <a:gs pos="100000">
+                <a:srgbClr val="7C4DFF"/>
+              </a:gs>
+            </a:gsLst>
+            <a:lin ang="0" scaled="0"/>
+          </a:gradFill>
+          <a:ln>
+            <a:noFill/>
           </a:ln>
           <a:effectLst/>
         </p:spPr>
@@ -17437,14 +18841,58 @@
       </p:sp>
       <p:sp>
         <p:nvSpPr>
-          <p:cNvPr id="25" name="TextBox 24"/>
+          <p:cNvPr id="25" name="Diamond 24"/>
+          <p:cNvSpPr/>
+          <p:nvPr/>
+        </p:nvSpPr>
+        <p:spPr>
+          <a:xfrm>
+            <a:off x="11471605" y="433654"/>
+            <a:ext cx="99578" cy="99578"/>
+          </a:xfrm>
+          <a:prstGeom prst="diamond">
+            <a:avLst/>
+          </a:prstGeom>
+          <a:solidFill>
+            <a:srgbClr val="38E0FF"/>
+          </a:solidFill>
+          <a:ln>
+            <a:noFill/>
+          </a:ln>
+          <a:effectLst/>
+        </p:spPr>
+        <p:style>
+          <a:lnRef idx="1">
+            <a:schemeClr val="accent1"/>
+          </a:lnRef>
+          <a:fillRef idx="3">
+            <a:schemeClr val="accent1"/>
+          </a:fillRef>
+          <a:effectRef idx="2">
+            <a:schemeClr val="accent1"/>
+          </a:effectRef>
+          <a:fontRef idx="minor">
+            <a:schemeClr val="lt1"/>
+          </a:fontRef>
+        </p:style>
+        <p:txBody>
+          <a:bodyPr rtlCol="0" anchor="ctr"/>
+          <a:lstStyle/>
+          <a:p>
+            <a:pPr algn="ctr"/>
+          </a:p>
+        </p:txBody>
+      </p:sp>
+      <p:sp>
+        <p:nvSpPr>
+          <p:cNvPr id="26" name="TextBox 25"/>
           <p:cNvSpPr txBox="1"/>
           <p:nvPr/>
         </p:nvSpPr>
         <p:spPr>
           <a:xfrm>
-            <a:off x="10241280" y="345440"/>
-            <a:ext cx="1645920" cy="251460"/>
+            <a:off x="10241280" y="864108"/>
+            <a:ext cx="1645920" cy="310896"/>
           </a:xfrm>
           <a:prstGeom prst="rect">
             <a:avLst/>
@@ -17463,7 +18911,7 @@
               </a:lnSpc>
             </a:pPr>
             <a:r>
-              <a:rPr sz="1100" b="1" i="0" spc="400">
+              <a:rPr sz="1800" b="1" i="0" spc="450">
                 <a:solidFill>
                   <a:srgbClr val="FFFFFF"/>
                 </a:solidFill>
@@ -17476,14 +18924,14 @@
       </p:sp>
       <p:sp>
         <p:nvSpPr>
-          <p:cNvPr id="26" name="TextBox 25"/>
+          <p:cNvPr id="27" name="TextBox 26"/>
           <p:cNvSpPr txBox="1"/>
           <p:nvPr/>
         </p:nvSpPr>
         <p:spPr>
           <a:xfrm>
-            <a:off x="10241280" y="571500"/>
-            <a:ext cx="1645920" cy="251460"/>
+            <a:off x="10241280" y="1175004"/>
+            <a:ext cx="1645920" cy="201168"/>
           </a:xfrm>
           <a:prstGeom prst="rect">
             <a:avLst/>
@@ -17502,7 +18950,7 @@
               </a:lnSpc>
             </a:pPr>
             <a:r>
-              <a:rPr sz="700" b="1" i="0" spc="500">
+              <a:rPr sz="900" b="1" i="0" spc="600">
                 <a:solidFill>
                   <a:srgbClr val="8EA0D6"/>
                 </a:solidFill>
@@ -18484,25 +19932,31 @@
       </p:sp>
       <p:sp>
         <p:nvSpPr>
-          <p:cNvPr id="24" name="Rounded Rectangle 23"/>
+          <p:cNvPr id="24" name="Block Arc 23"/>
           <p:cNvSpPr/>
           <p:nvPr/>
         </p:nvSpPr>
         <p:spPr>
           <a:xfrm>
-            <a:off x="10241280" y="320040"/>
-            <a:ext cx="1645920" cy="502920"/>
-          </a:xfrm>
-          <a:prstGeom prst="roundRect">
-            <a:avLst/>
-          </a:prstGeom>
-          <a:solidFill>
-            <a:srgbClr val="0C1230"/>
-          </a:solidFill>
-          <a:ln w="9525">
-            <a:solidFill>
-              <a:srgbClr val="9A7BFF"/>
-            </a:solidFill>
+            <a:off x="10611612" y="365760"/>
+            <a:ext cx="905256" cy="452628"/>
+          </a:xfrm>
+          <a:prstGeom prst="blockArc">
+            <a:avLst/>
+          </a:prstGeom>
+          <a:gradFill flip="none" rotWithShape="1">
+            <a:gsLst>
+              <a:gs pos="0">
+                <a:srgbClr val="38E0FF"/>
+              </a:gs>
+              <a:gs pos="100000">
+                <a:srgbClr val="7C4DFF"/>
+              </a:gs>
+            </a:gsLst>
+            <a:lin ang="0" scaled="0"/>
+          </a:gradFill>
+          <a:ln>
+            <a:noFill/>
           </a:ln>
           <a:effectLst/>
         </p:spPr>
@@ -18530,14 +19984,58 @@
       </p:sp>
       <p:sp>
         <p:nvSpPr>
-          <p:cNvPr id="25" name="TextBox 24"/>
+          <p:cNvPr id="25" name="Diamond 24"/>
+          <p:cNvSpPr/>
+          <p:nvPr/>
+        </p:nvSpPr>
+        <p:spPr>
+          <a:xfrm>
+            <a:off x="11471605" y="433654"/>
+            <a:ext cx="99578" cy="99578"/>
+          </a:xfrm>
+          <a:prstGeom prst="diamond">
+            <a:avLst/>
+          </a:prstGeom>
+          <a:solidFill>
+            <a:srgbClr val="38E0FF"/>
+          </a:solidFill>
+          <a:ln>
+            <a:noFill/>
+          </a:ln>
+          <a:effectLst/>
+        </p:spPr>
+        <p:style>
+          <a:lnRef idx="1">
+            <a:schemeClr val="accent1"/>
+          </a:lnRef>
+          <a:fillRef idx="3">
+            <a:schemeClr val="accent1"/>
+          </a:fillRef>
+          <a:effectRef idx="2">
+            <a:schemeClr val="accent1"/>
+          </a:effectRef>
+          <a:fontRef idx="minor">
+            <a:schemeClr val="lt1"/>
+          </a:fontRef>
+        </p:style>
+        <p:txBody>
+          <a:bodyPr rtlCol="0" anchor="ctr"/>
+          <a:lstStyle/>
+          <a:p>
+            <a:pPr algn="ctr"/>
+          </a:p>
+        </p:txBody>
+      </p:sp>
+      <p:sp>
+        <p:nvSpPr>
+          <p:cNvPr id="26" name="TextBox 25"/>
           <p:cNvSpPr txBox="1"/>
           <p:nvPr/>
         </p:nvSpPr>
         <p:spPr>
           <a:xfrm>
-            <a:off x="10241280" y="345440"/>
-            <a:ext cx="1645920" cy="251460"/>
+            <a:off x="10241280" y="864108"/>
+            <a:ext cx="1645920" cy="310896"/>
           </a:xfrm>
           <a:prstGeom prst="rect">
             <a:avLst/>
@@ -18556,7 +20054,7 @@
               </a:lnSpc>
             </a:pPr>
             <a:r>
-              <a:rPr sz="1100" b="1" i="0" spc="400">
+              <a:rPr sz="1800" b="1" i="0" spc="450">
                 <a:solidFill>
                   <a:srgbClr val="FFFFFF"/>
                 </a:solidFill>
@@ -18569,14 +20067,14 @@
       </p:sp>
       <p:sp>
         <p:nvSpPr>
-          <p:cNvPr id="26" name="TextBox 25"/>
+          <p:cNvPr id="27" name="TextBox 26"/>
           <p:cNvSpPr txBox="1"/>
           <p:nvPr/>
         </p:nvSpPr>
         <p:spPr>
           <a:xfrm>
-            <a:off x="10241280" y="571500"/>
-            <a:ext cx="1645920" cy="251460"/>
+            <a:off x="10241280" y="1175004"/>
+            <a:ext cx="1645920" cy="201168"/>
           </a:xfrm>
           <a:prstGeom prst="rect">
             <a:avLst/>
@@ -18595,7 +20093,7 @@
               </a:lnSpc>
             </a:pPr>
             <a:r>
-              <a:rPr sz="700" b="1" i="0" spc="500">
+              <a:rPr sz="900" b="1" i="0" spc="600">
                 <a:solidFill>
                   <a:srgbClr val="8EA0D6"/>
                 </a:solidFill>
@@ -19448,25 +20946,31 @@
       </p:sp>
       <p:sp>
         <p:nvSpPr>
-          <p:cNvPr id="21" name="Rounded Rectangle 20"/>
+          <p:cNvPr id="21" name="Block Arc 20"/>
           <p:cNvSpPr/>
           <p:nvPr/>
         </p:nvSpPr>
         <p:spPr>
           <a:xfrm>
-            <a:off x="10241280" y="320040"/>
-            <a:ext cx="1645920" cy="502920"/>
-          </a:xfrm>
-          <a:prstGeom prst="roundRect">
-            <a:avLst/>
-          </a:prstGeom>
-          <a:solidFill>
-            <a:srgbClr val="0C1230"/>
-          </a:solidFill>
-          <a:ln w="9525">
-            <a:solidFill>
-              <a:srgbClr val="9A7BFF"/>
-            </a:solidFill>
+            <a:off x="10611612" y="365760"/>
+            <a:ext cx="905256" cy="452628"/>
+          </a:xfrm>
+          <a:prstGeom prst="blockArc">
+            <a:avLst/>
+          </a:prstGeom>
+          <a:gradFill flip="none" rotWithShape="1">
+            <a:gsLst>
+              <a:gs pos="0">
+                <a:srgbClr val="38E0FF"/>
+              </a:gs>
+              <a:gs pos="100000">
+                <a:srgbClr val="7C4DFF"/>
+              </a:gs>
+            </a:gsLst>
+            <a:lin ang="0" scaled="0"/>
+          </a:gradFill>
+          <a:ln>
+            <a:noFill/>
           </a:ln>
           <a:effectLst/>
         </p:spPr>
@@ -19494,14 +20998,58 @@
       </p:sp>
       <p:sp>
         <p:nvSpPr>
-          <p:cNvPr id="22" name="TextBox 21"/>
+          <p:cNvPr id="22" name="Diamond 21"/>
+          <p:cNvSpPr/>
+          <p:nvPr/>
+        </p:nvSpPr>
+        <p:spPr>
+          <a:xfrm>
+            <a:off x="11471605" y="433654"/>
+            <a:ext cx="99578" cy="99578"/>
+          </a:xfrm>
+          <a:prstGeom prst="diamond">
+            <a:avLst/>
+          </a:prstGeom>
+          <a:solidFill>
+            <a:srgbClr val="38E0FF"/>
+          </a:solidFill>
+          <a:ln>
+            <a:noFill/>
+          </a:ln>
+          <a:effectLst/>
+        </p:spPr>
+        <p:style>
+          <a:lnRef idx="1">
+            <a:schemeClr val="accent1"/>
+          </a:lnRef>
+          <a:fillRef idx="3">
+            <a:schemeClr val="accent1"/>
+          </a:fillRef>
+          <a:effectRef idx="2">
+            <a:schemeClr val="accent1"/>
+          </a:effectRef>
+          <a:fontRef idx="minor">
+            <a:schemeClr val="lt1"/>
+          </a:fontRef>
+        </p:style>
+        <p:txBody>
+          <a:bodyPr rtlCol="0" anchor="ctr"/>
+          <a:lstStyle/>
+          <a:p>
+            <a:pPr algn="ctr"/>
+          </a:p>
+        </p:txBody>
+      </p:sp>
+      <p:sp>
+        <p:nvSpPr>
+          <p:cNvPr id="23" name="TextBox 22"/>
           <p:cNvSpPr txBox="1"/>
           <p:nvPr/>
         </p:nvSpPr>
         <p:spPr>
           <a:xfrm>
-            <a:off x="10241280" y="345440"/>
-            <a:ext cx="1645920" cy="251460"/>
+            <a:off x="10241280" y="864108"/>
+            <a:ext cx="1645920" cy="310896"/>
           </a:xfrm>
           <a:prstGeom prst="rect">
             <a:avLst/>
@@ -19520,7 +21068,7 @@
               </a:lnSpc>
             </a:pPr>
             <a:r>
-              <a:rPr sz="1100" b="1" i="0" spc="400">
+              <a:rPr sz="1800" b="1" i="0" spc="450">
                 <a:solidFill>
                   <a:srgbClr val="FFFFFF"/>
                 </a:solidFill>
@@ -19533,14 +21081,14 @@
       </p:sp>
       <p:sp>
         <p:nvSpPr>
-          <p:cNvPr id="23" name="TextBox 22"/>
+          <p:cNvPr id="24" name="TextBox 23"/>
           <p:cNvSpPr txBox="1"/>
           <p:nvPr/>
         </p:nvSpPr>
         <p:spPr>
           <a:xfrm>
-            <a:off x="10241280" y="571500"/>
-            <a:ext cx="1645920" cy="251460"/>
+            <a:off x="10241280" y="1175004"/>
+            <a:ext cx="1645920" cy="201168"/>
           </a:xfrm>
           <a:prstGeom prst="rect">
             <a:avLst/>
@@ -19559,7 +21107,7 @@
               </a:lnSpc>
             </a:pPr>
             <a:r>
-              <a:rPr sz="700" b="1" i="0" spc="500">
+              <a:rPr sz="900" b="1" i="0" spc="600">
                 <a:solidFill>
                   <a:srgbClr val="8EA0D6"/>
                 </a:solidFill>

</xml_diff>